<commit_message>
Add Mantra.ai favicon across MoU, pitch deck, and web app.
Embed the navy M+infinity mark in the MoU header, industry readiness PPT, and app chrome (favicon, login, sidebar) for consistent branding.

Co-authored-by: Cursor <cursoragent@cursor.com>
</commit_message>
<xml_diff>
--- a/docs/AI_NextGen_Industry_Readiness_Pitch.pptx
+++ b/docs/AI_NextGen_Industry_Readiness_Pitch.pptx
@@ -5,14 +5,14 @@
     <p:sldMasterId id="2147483648" r:id="rId1"/>
   </p:sldMasterIdLst>
   <p:sldIdLst>
-    <p:sldId id="256" r:id="rId2"/>
-    <p:sldId id="257" r:id="rId3"/>
-    <p:sldId id="258" r:id="rId4"/>
-    <p:sldId id="259" r:id="rId5"/>
-    <p:sldId id="260" r:id="rId6"/>
-    <p:sldId id="261" r:id="rId7"/>
-    <p:sldId id="262" r:id="rId8"/>
-    <p:sldId id="263" r:id="rId9"/>
+    <p:sldId id="256" r:id="rId7"/>
+    <p:sldId id="257" r:id="rId8"/>
+    <p:sldId id="258" r:id="rId9"/>
+    <p:sldId id="259" r:id="rId10"/>
+    <p:sldId id="260" r:id="rId11"/>
+    <p:sldId id="261" r:id="rId12"/>
+    <p:sldId id="262" r:id="rId13"/>
+    <p:sldId id="263" r:id="rId14"/>
   </p:sldIdLst>
   <p:sldSz cx="9144000" cy="6858000" type="screen4x3"/>
   <p:notesSz cx="6858000" cy="9144000"/>
@@ -111,22 +111,6 @@
       </a:defRPr>
     </a:lvl9pPr>
   </p:defaultTextStyle>
-  <p:extLst>
-    <p:ext uri="{EFAFB233-063F-42B5-8137-9DF3F51BA10A}">
-      <p15:sldGuideLst xmlns:p15="http://schemas.microsoft.com/office/powerpoint/2012/main">
-        <p15:guide id="1" orient="horz" pos="2160">
-          <p15:clr>
-            <a:srgbClr val="A4A3A4"/>
-          </p15:clr>
-        </p15:guide>
-        <p15:guide id="2" pos="2880">
-          <p15:clr>
-            <a:srgbClr val="A4A3A4"/>
-          </p15:clr>
-        </p15:guide>
-      </p15:sldGuideLst>
-    </p:ext>
-  </p:extLst>
 </p:presentation>
 </file>
 
@@ -168,9 +152,10 @@
           <a:lstStyle/>
           <a:p>
             <a:r>
-              <a:rPr lang="en-US"/>
+              <a:rPr lang="en-US" smtClean="0"/>
               <a:t>Click to edit Master title style</a:t>
             </a:r>
+            <a:endParaRPr lang="en-US"/>
           </a:p>
         </p:txBody>
       </p:sp>
@@ -286,9 +271,10 @@
           </a:lstStyle>
           <a:p>
             <a:r>
-              <a:rPr lang="en-US"/>
+              <a:rPr lang="en-US" smtClean="0"/>
               <a:t>Click to edit Master subtitle style</a:t>
             </a:r>
+            <a:endParaRPr lang="en-US"/>
           </a:p>
         </p:txBody>
       </p:sp>
@@ -309,7 +295,7 @@
           <a:p>
             <a:fld id="{5BCAD085-E8A6-8845-BD4E-CB4CCA059FC4}" type="datetimeFigureOut">
               <a:rPr lang="en-US" smtClean="0"/>
-              <a:t>6/18/26</a:t>
+              <a:t>1/27/13</a:t>
             </a:fld>
             <a:endParaRPr lang="en-US"/>
           </a:p>
@@ -403,9 +389,10 @@
           <a:lstStyle/>
           <a:p>
             <a:r>
-              <a:rPr lang="en-US"/>
+              <a:rPr lang="en-US" smtClean="0"/>
               <a:t>Click to edit Master title style</a:t>
             </a:r>
+            <a:endParaRPr lang="en-US"/>
           </a:p>
         </p:txBody>
       </p:sp>
@@ -426,37 +413,38 @@
           <a:p>
             <a:pPr lvl="0"/>
             <a:r>
-              <a:rPr lang="en-US"/>
+              <a:rPr lang="en-US" smtClean="0"/>
               <a:t>Click to edit Master text styles</a:t>
             </a:r>
           </a:p>
           <a:p>
             <a:pPr lvl="1"/>
             <a:r>
-              <a:rPr lang="en-US"/>
+              <a:rPr lang="en-US" smtClean="0"/>
               <a:t>Second level</a:t>
             </a:r>
           </a:p>
           <a:p>
             <a:pPr lvl="2"/>
             <a:r>
-              <a:rPr lang="en-US"/>
+              <a:rPr lang="en-US" smtClean="0"/>
               <a:t>Third level</a:t>
             </a:r>
           </a:p>
           <a:p>
             <a:pPr lvl="3"/>
             <a:r>
-              <a:rPr lang="en-US"/>
+              <a:rPr lang="en-US" smtClean="0"/>
               <a:t>Fourth level</a:t>
             </a:r>
           </a:p>
           <a:p>
             <a:pPr lvl="4"/>
             <a:r>
-              <a:rPr lang="en-US"/>
+              <a:rPr lang="en-US" smtClean="0"/>
               <a:t>Fifth level</a:t>
             </a:r>
+            <a:endParaRPr lang="en-US"/>
           </a:p>
         </p:txBody>
       </p:sp>
@@ -477,7 +465,7 @@
           <a:p>
             <a:fld id="{5BCAD085-E8A6-8845-BD4E-CB4CCA059FC4}" type="datetimeFigureOut">
               <a:rPr lang="en-US" smtClean="0"/>
-              <a:t>6/18/26</a:t>
+              <a:t>1/27/13</a:t>
             </a:fld>
             <a:endParaRPr lang="en-US"/>
           </a:p>
@@ -576,9 +564,10 @@
           <a:lstStyle/>
           <a:p>
             <a:r>
-              <a:rPr lang="en-US"/>
+              <a:rPr lang="en-US" smtClean="0"/>
               <a:t>Click to edit Master title style</a:t>
             </a:r>
+            <a:endParaRPr lang="en-US"/>
           </a:p>
         </p:txBody>
       </p:sp>
@@ -604,37 +593,38 @@
           <a:p>
             <a:pPr lvl="0"/>
             <a:r>
-              <a:rPr lang="en-US"/>
+              <a:rPr lang="en-US" smtClean="0"/>
               <a:t>Click to edit Master text styles</a:t>
             </a:r>
           </a:p>
           <a:p>
             <a:pPr lvl="1"/>
             <a:r>
-              <a:rPr lang="en-US"/>
+              <a:rPr lang="en-US" smtClean="0"/>
               <a:t>Second level</a:t>
             </a:r>
           </a:p>
           <a:p>
             <a:pPr lvl="2"/>
             <a:r>
-              <a:rPr lang="en-US"/>
+              <a:rPr lang="en-US" smtClean="0"/>
               <a:t>Third level</a:t>
             </a:r>
           </a:p>
           <a:p>
             <a:pPr lvl="3"/>
             <a:r>
-              <a:rPr lang="en-US"/>
+              <a:rPr lang="en-US" smtClean="0"/>
               <a:t>Fourth level</a:t>
             </a:r>
           </a:p>
           <a:p>
             <a:pPr lvl="4"/>
             <a:r>
-              <a:rPr lang="en-US"/>
+              <a:rPr lang="en-US" smtClean="0"/>
               <a:t>Fifth level</a:t>
             </a:r>
+            <a:endParaRPr lang="en-US"/>
           </a:p>
         </p:txBody>
       </p:sp>
@@ -655,7 +645,7 @@
           <a:p>
             <a:fld id="{5BCAD085-E8A6-8845-BD4E-CB4CCA059FC4}" type="datetimeFigureOut">
               <a:rPr lang="en-US" smtClean="0"/>
-              <a:t>6/18/26</a:t>
+              <a:t>1/27/13</a:t>
             </a:fld>
             <a:endParaRPr lang="en-US"/>
           </a:p>
@@ -749,9 +739,10 @@
           <a:lstStyle/>
           <a:p>
             <a:r>
-              <a:rPr lang="en-US"/>
+              <a:rPr lang="en-US" smtClean="0"/>
               <a:t>Click to edit Master title style</a:t>
             </a:r>
+            <a:endParaRPr lang="en-US"/>
           </a:p>
         </p:txBody>
       </p:sp>
@@ -772,37 +763,38 @@
           <a:p>
             <a:pPr lvl="0"/>
             <a:r>
-              <a:rPr lang="en-US"/>
+              <a:rPr lang="en-US" smtClean="0"/>
               <a:t>Click to edit Master text styles</a:t>
             </a:r>
           </a:p>
           <a:p>
             <a:pPr lvl="1"/>
             <a:r>
-              <a:rPr lang="en-US"/>
+              <a:rPr lang="en-US" smtClean="0"/>
               <a:t>Second level</a:t>
             </a:r>
           </a:p>
           <a:p>
             <a:pPr lvl="2"/>
             <a:r>
-              <a:rPr lang="en-US"/>
+              <a:rPr lang="en-US" smtClean="0"/>
               <a:t>Third level</a:t>
             </a:r>
           </a:p>
           <a:p>
             <a:pPr lvl="3"/>
             <a:r>
-              <a:rPr lang="en-US"/>
+              <a:rPr lang="en-US" smtClean="0"/>
               <a:t>Fourth level</a:t>
             </a:r>
           </a:p>
           <a:p>
             <a:pPr lvl="4"/>
             <a:r>
-              <a:rPr lang="en-US"/>
+              <a:rPr lang="en-US" smtClean="0"/>
               <a:t>Fifth level</a:t>
             </a:r>
+            <a:endParaRPr lang="en-US"/>
           </a:p>
         </p:txBody>
       </p:sp>
@@ -823,7 +815,7 @@
           <a:p>
             <a:fld id="{5BCAD085-E8A6-8845-BD4E-CB4CCA059FC4}" type="datetimeFigureOut">
               <a:rPr lang="en-US" smtClean="0"/>
-              <a:t>6/18/26</a:t>
+              <a:t>1/27/13</a:t>
             </a:fld>
             <a:endParaRPr lang="en-US"/>
           </a:p>
@@ -926,9 +918,10 @@
           </a:lstStyle>
           <a:p>
             <a:r>
-              <a:rPr lang="en-US"/>
+              <a:rPr lang="en-US" smtClean="0"/>
               <a:t>Click to edit Master title style</a:t>
             </a:r>
+            <a:endParaRPr lang="en-US"/>
           </a:p>
         </p:txBody>
       </p:sp>
@@ -1045,7 +1038,7 @@
           <a:p>
             <a:pPr lvl="0"/>
             <a:r>
-              <a:rPr lang="en-US"/>
+              <a:rPr lang="en-US" smtClean="0"/>
               <a:t>Click to edit Master text styles</a:t>
             </a:r>
           </a:p>
@@ -1068,7 +1061,7 @@
           <a:p>
             <a:fld id="{5BCAD085-E8A6-8845-BD4E-CB4CCA059FC4}" type="datetimeFigureOut">
               <a:rPr lang="en-US" smtClean="0"/>
-              <a:t>6/18/26</a:t>
+              <a:t>1/27/13</a:t>
             </a:fld>
             <a:endParaRPr lang="en-US"/>
           </a:p>
@@ -1162,9 +1155,10 @@
           <a:lstStyle/>
           <a:p>
             <a:r>
-              <a:rPr lang="en-US"/>
+              <a:rPr lang="en-US" smtClean="0"/>
               <a:t>Click to edit Master title style</a:t>
             </a:r>
+            <a:endParaRPr lang="en-US"/>
           </a:p>
         </p:txBody>
       </p:sp>
@@ -1218,37 +1212,38 @@
           <a:p>
             <a:pPr lvl="0"/>
             <a:r>
-              <a:rPr lang="en-US"/>
+              <a:rPr lang="en-US" smtClean="0"/>
               <a:t>Click to edit Master text styles</a:t>
             </a:r>
           </a:p>
           <a:p>
             <a:pPr lvl="1"/>
             <a:r>
-              <a:rPr lang="en-US"/>
+              <a:rPr lang="en-US" smtClean="0"/>
               <a:t>Second level</a:t>
             </a:r>
           </a:p>
           <a:p>
             <a:pPr lvl="2"/>
             <a:r>
-              <a:rPr lang="en-US"/>
+              <a:rPr lang="en-US" smtClean="0"/>
               <a:t>Third level</a:t>
             </a:r>
           </a:p>
           <a:p>
             <a:pPr lvl="3"/>
             <a:r>
-              <a:rPr lang="en-US"/>
+              <a:rPr lang="en-US" smtClean="0"/>
               <a:t>Fourth level</a:t>
             </a:r>
           </a:p>
           <a:p>
             <a:pPr lvl="4"/>
             <a:r>
-              <a:rPr lang="en-US"/>
+              <a:rPr lang="en-US" smtClean="0"/>
               <a:t>Fifth level</a:t>
             </a:r>
+            <a:endParaRPr lang="en-US"/>
           </a:p>
         </p:txBody>
       </p:sp>
@@ -1302,37 +1297,38 @@
           <a:p>
             <a:pPr lvl="0"/>
             <a:r>
-              <a:rPr lang="en-US"/>
+              <a:rPr lang="en-US" smtClean="0"/>
               <a:t>Click to edit Master text styles</a:t>
             </a:r>
           </a:p>
           <a:p>
             <a:pPr lvl="1"/>
             <a:r>
-              <a:rPr lang="en-US"/>
+              <a:rPr lang="en-US" smtClean="0"/>
               <a:t>Second level</a:t>
             </a:r>
           </a:p>
           <a:p>
             <a:pPr lvl="2"/>
             <a:r>
-              <a:rPr lang="en-US"/>
+              <a:rPr lang="en-US" smtClean="0"/>
               <a:t>Third level</a:t>
             </a:r>
           </a:p>
           <a:p>
             <a:pPr lvl="3"/>
             <a:r>
-              <a:rPr lang="en-US"/>
+              <a:rPr lang="en-US" smtClean="0"/>
               <a:t>Fourth level</a:t>
             </a:r>
           </a:p>
           <a:p>
             <a:pPr lvl="4"/>
             <a:r>
-              <a:rPr lang="en-US"/>
+              <a:rPr lang="en-US" smtClean="0"/>
               <a:t>Fifth level</a:t>
             </a:r>
+            <a:endParaRPr lang="en-US"/>
           </a:p>
         </p:txBody>
       </p:sp>
@@ -1353,7 +1349,7 @@
           <a:p>
             <a:fld id="{5BCAD085-E8A6-8845-BD4E-CB4CCA059FC4}" type="datetimeFigureOut">
               <a:rPr lang="en-US" smtClean="0"/>
-              <a:t>6/18/26</a:t>
+              <a:t>1/27/13</a:t>
             </a:fld>
             <a:endParaRPr lang="en-US"/>
           </a:p>
@@ -1451,9 +1447,10 @@
           </a:lstStyle>
           <a:p>
             <a:r>
-              <a:rPr lang="en-US"/>
+              <a:rPr lang="en-US" smtClean="0"/>
               <a:t>Click to edit Master title style</a:t>
             </a:r>
+            <a:endParaRPr lang="en-US"/>
           </a:p>
         </p:txBody>
       </p:sp>
@@ -1516,7 +1513,7 @@
           <a:p>
             <a:pPr lvl="0"/>
             <a:r>
-              <a:rPr lang="en-US"/>
+              <a:rPr lang="en-US" smtClean="0"/>
               <a:t>Click to edit Master text styles</a:t>
             </a:r>
           </a:p>
@@ -1572,37 +1569,38 @@
           <a:p>
             <a:pPr lvl="0"/>
             <a:r>
-              <a:rPr lang="en-US"/>
+              <a:rPr lang="en-US" smtClean="0"/>
               <a:t>Click to edit Master text styles</a:t>
             </a:r>
           </a:p>
           <a:p>
             <a:pPr lvl="1"/>
             <a:r>
-              <a:rPr lang="en-US"/>
+              <a:rPr lang="en-US" smtClean="0"/>
               <a:t>Second level</a:t>
             </a:r>
           </a:p>
           <a:p>
             <a:pPr lvl="2"/>
             <a:r>
-              <a:rPr lang="en-US"/>
+              <a:rPr lang="en-US" smtClean="0"/>
               <a:t>Third level</a:t>
             </a:r>
           </a:p>
           <a:p>
             <a:pPr lvl="3"/>
             <a:r>
-              <a:rPr lang="en-US"/>
+              <a:rPr lang="en-US" smtClean="0"/>
               <a:t>Fourth level</a:t>
             </a:r>
           </a:p>
           <a:p>
             <a:pPr lvl="4"/>
             <a:r>
-              <a:rPr lang="en-US"/>
+              <a:rPr lang="en-US" smtClean="0"/>
               <a:t>Fifth level</a:t>
             </a:r>
+            <a:endParaRPr lang="en-US"/>
           </a:p>
         </p:txBody>
       </p:sp>
@@ -1665,7 +1663,7 @@
           <a:p>
             <a:pPr lvl="0"/>
             <a:r>
-              <a:rPr lang="en-US"/>
+              <a:rPr lang="en-US" smtClean="0"/>
               <a:t>Click to edit Master text styles</a:t>
             </a:r>
           </a:p>
@@ -1721,37 +1719,38 @@
           <a:p>
             <a:pPr lvl="0"/>
             <a:r>
-              <a:rPr lang="en-US"/>
+              <a:rPr lang="en-US" smtClean="0"/>
               <a:t>Click to edit Master text styles</a:t>
             </a:r>
           </a:p>
           <a:p>
             <a:pPr lvl="1"/>
             <a:r>
-              <a:rPr lang="en-US"/>
+              <a:rPr lang="en-US" smtClean="0"/>
               <a:t>Second level</a:t>
             </a:r>
           </a:p>
           <a:p>
             <a:pPr lvl="2"/>
             <a:r>
-              <a:rPr lang="en-US"/>
+              <a:rPr lang="en-US" smtClean="0"/>
               <a:t>Third level</a:t>
             </a:r>
           </a:p>
           <a:p>
             <a:pPr lvl="3"/>
             <a:r>
-              <a:rPr lang="en-US"/>
+              <a:rPr lang="en-US" smtClean="0"/>
               <a:t>Fourth level</a:t>
             </a:r>
           </a:p>
           <a:p>
             <a:pPr lvl="4"/>
             <a:r>
-              <a:rPr lang="en-US"/>
+              <a:rPr lang="en-US" smtClean="0"/>
               <a:t>Fifth level</a:t>
             </a:r>
+            <a:endParaRPr lang="en-US"/>
           </a:p>
         </p:txBody>
       </p:sp>
@@ -1772,7 +1771,7 @@
           <a:p>
             <a:fld id="{5BCAD085-E8A6-8845-BD4E-CB4CCA059FC4}" type="datetimeFigureOut">
               <a:rPr lang="en-US" smtClean="0"/>
-              <a:t>6/18/26</a:t>
+              <a:t>1/27/13</a:t>
             </a:fld>
             <a:endParaRPr lang="en-US"/>
           </a:p>
@@ -1866,9 +1865,10 @@
           <a:lstStyle/>
           <a:p>
             <a:r>
-              <a:rPr lang="en-US"/>
+              <a:rPr lang="en-US" smtClean="0"/>
               <a:t>Click to edit Master title style</a:t>
             </a:r>
+            <a:endParaRPr lang="en-US"/>
           </a:p>
         </p:txBody>
       </p:sp>
@@ -1889,7 +1889,7 @@
           <a:p>
             <a:fld id="{5BCAD085-E8A6-8845-BD4E-CB4CCA059FC4}" type="datetimeFigureOut">
               <a:rPr lang="en-US" smtClean="0"/>
-              <a:t>6/18/26</a:t>
+              <a:t>1/27/13</a:t>
             </a:fld>
             <a:endParaRPr lang="en-US"/>
           </a:p>
@@ -1984,7 +1984,7 @@
           <a:p>
             <a:fld id="{5BCAD085-E8A6-8845-BD4E-CB4CCA059FC4}" type="datetimeFigureOut">
               <a:rPr lang="en-US" smtClean="0"/>
-              <a:t>6/18/26</a:t>
+              <a:t>1/27/13</a:t>
             </a:fld>
             <a:endParaRPr lang="en-US"/>
           </a:p>
@@ -2087,9 +2087,10 @@
           </a:lstStyle>
           <a:p>
             <a:r>
-              <a:rPr lang="en-US"/>
+              <a:rPr lang="en-US" smtClean="0"/>
               <a:t>Click to edit Master title style</a:t>
             </a:r>
+            <a:endParaRPr lang="en-US"/>
           </a:p>
         </p:txBody>
       </p:sp>
@@ -2143,37 +2144,38 @@
           <a:p>
             <a:pPr lvl="0"/>
             <a:r>
-              <a:rPr lang="en-US"/>
+              <a:rPr lang="en-US" smtClean="0"/>
               <a:t>Click to edit Master text styles</a:t>
             </a:r>
           </a:p>
           <a:p>
             <a:pPr lvl="1"/>
             <a:r>
-              <a:rPr lang="en-US"/>
+              <a:rPr lang="en-US" smtClean="0"/>
               <a:t>Second level</a:t>
             </a:r>
           </a:p>
           <a:p>
             <a:pPr lvl="2"/>
             <a:r>
-              <a:rPr lang="en-US"/>
+              <a:rPr lang="en-US" smtClean="0"/>
               <a:t>Third level</a:t>
             </a:r>
           </a:p>
           <a:p>
             <a:pPr lvl="3"/>
             <a:r>
-              <a:rPr lang="en-US"/>
+              <a:rPr lang="en-US" smtClean="0"/>
               <a:t>Fourth level</a:t>
             </a:r>
           </a:p>
           <a:p>
             <a:pPr lvl="4"/>
             <a:r>
-              <a:rPr lang="en-US"/>
+              <a:rPr lang="en-US" smtClean="0"/>
               <a:t>Fifth level</a:t>
             </a:r>
+            <a:endParaRPr lang="en-US"/>
           </a:p>
         </p:txBody>
       </p:sp>
@@ -2236,7 +2238,7 @@
           <a:p>
             <a:pPr lvl="0"/>
             <a:r>
-              <a:rPr lang="en-US"/>
+              <a:rPr lang="en-US" smtClean="0"/>
               <a:t>Click to edit Master text styles</a:t>
             </a:r>
           </a:p>
@@ -2259,7 +2261,7 @@
           <a:p>
             <a:fld id="{5BCAD085-E8A6-8845-BD4E-CB4CCA059FC4}" type="datetimeFigureOut">
               <a:rPr lang="en-US" smtClean="0"/>
-              <a:t>6/18/26</a:t>
+              <a:t>1/27/13</a:t>
             </a:fld>
             <a:endParaRPr lang="en-US"/>
           </a:p>
@@ -2362,9 +2364,10 @@
           </a:lstStyle>
           <a:p>
             <a:r>
-              <a:rPr lang="en-US"/>
+              <a:rPr lang="en-US" smtClean="0"/>
               <a:t>Click to edit Master title style</a:t>
             </a:r>
+            <a:endParaRPr lang="en-US"/>
           </a:p>
         </p:txBody>
       </p:sp>
@@ -2488,7 +2491,7 @@
           <a:p>
             <a:pPr lvl="0"/>
             <a:r>
-              <a:rPr lang="en-US"/>
+              <a:rPr lang="en-US" smtClean="0"/>
               <a:t>Click to edit Master text styles</a:t>
             </a:r>
           </a:p>
@@ -2511,7 +2514,7 @@
           <a:p>
             <a:fld id="{5BCAD085-E8A6-8845-BD4E-CB4CCA059FC4}" type="datetimeFigureOut">
               <a:rPr lang="en-US" smtClean="0"/>
-              <a:t>6/18/26</a:t>
+              <a:t>1/27/13</a:t>
             </a:fld>
             <a:endParaRPr lang="en-US"/>
           </a:p>
@@ -2620,9 +2623,10 @@
           <a:lstStyle/>
           <a:p>
             <a:r>
-              <a:rPr lang="en-US"/>
+              <a:rPr lang="en-US" smtClean="0"/>
               <a:t>Click to edit Master title style</a:t>
             </a:r>
+            <a:endParaRPr lang="en-US"/>
           </a:p>
         </p:txBody>
       </p:sp>
@@ -2653,37 +2657,38 @@
           <a:p>
             <a:pPr lvl="0"/>
             <a:r>
-              <a:rPr lang="en-US"/>
+              <a:rPr lang="en-US" smtClean="0"/>
               <a:t>Click to edit Master text styles</a:t>
             </a:r>
           </a:p>
           <a:p>
             <a:pPr lvl="1"/>
             <a:r>
-              <a:rPr lang="en-US"/>
+              <a:rPr lang="en-US" smtClean="0"/>
               <a:t>Second level</a:t>
             </a:r>
           </a:p>
           <a:p>
             <a:pPr lvl="2"/>
             <a:r>
-              <a:rPr lang="en-US"/>
+              <a:rPr lang="en-US" smtClean="0"/>
               <a:t>Third level</a:t>
             </a:r>
           </a:p>
           <a:p>
             <a:pPr lvl="3"/>
             <a:r>
-              <a:rPr lang="en-US"/>
+              <a:rPr lang="en-US" smtClean="0"/>
               <a:t>Fourth level</a:t>
             </a:r>
           </a:p>
           <a:p>
             <a:pPr lvl="4"/>
             <a:r>
-              <a:rPr lang="en-US"/>
+              <a:rPr lang="en-US" smtClean="0"/>
               <a:t>Fifth level</a:t>
             </a:r>
+            <a:endParaRPr lang="en-US"/>
           </a:p>
         </p:txBody>
       </p:sp>
@@ -2722,7 +2727,7 @@
           <a:p>
             <a:fld id="{5BCAD085-E8A6-8845-BD4E-CB4CCA059FC4}" type="datetimeFigureOut">
               <a:rPr lang="en-US" smtClean="0"/>
-              <a:t>6/18/26</a:t>
+              <a:t>1/27/13</a:t>
             </a:fld>
             <a:endParaRPr lang="en-US"/>
           </a:p>
@@ -3081,7 +3086,7 @@
 </file>
 
 <file path=ppt/slides/slide1.xml><?xml version="1.0" encoding="utf-8"?>
-<p:sld xmlns:a="http://schemas.openxmlformats.org/drawingml/2006/main" xmlns:r="http://schemas.openxmlformats.org/officeDocument/2006/relationships" xmlns:p="http://schemas.openxmlformats.org/presentationml/2006/main">
+<p:sld xmlns:a="http://schemas.openxmlformats.org/drawingml/2006/main" xmlns:p="http://schemas.openxmlformats.org/presentationml/2006/main" xmlns:r="http://schemas.openxmlformats.org/officeDocument/2006/relationships">
   <p:cSld>
     <p:bg>
       <p:bgPr>
@@ -3097,14 +3102,7 @@
         <p:cNvGrpSpPr/>
         <p:nvPr/>
       </p:nvGrpSpPr>
-      <p:grpSpPr>
-        <a:xfrm>
-          <a:off x="0" y="0"/>
-          <a:ext cx="0" cy="0"/>
-          <a:chOff x="0" y="0"/>
-          <a:chExt cx="0" cy="0"/>
-        </a:xfrm>
-      </p:grpSpPr>
+      <p:grpSpPr/>
       <p:sp>
         <p:nvSpPr>
           <p:cNvPr id="2" name="Rectangle 1"/>
@@ -3145,20 +3143,43 @@
           <a:lstStyle/>
           <a:p>
             <a:pPr algn="ctr"/>
-            <a:endParaRPr/>
-          </a:p>
-        </p:txBody>
-      </p:sp>
-      <p:sp>
-        <p:nvSpPr>
-          <p:cNvPr id="5" name="TextBox 4"/>
+          </a:p>
+        </p:txBody>
+      </p:sp>
+      <p:pic>
+        <p:nvPicPr>
+          <p:cNvPr id="3" name="Picture 2" descr="mantra-ai-favicon.png"/>
+          <p:cNvPicPr>
+            <a:picLocks noChangeAspect="1"/>
+          </p:cNvPicPr>
+          <p:nvPr/>
+        </p:nvPicPr>
+        <p:blipFill>
+          <a:blip r:embed="rId2"/>
+          <a:stretch>
+            <a:fillRect/>
+          </a:stretch>
+        </p:blipFill>
+        <p:spPr>
+          <a:xfrm>
+            <a:off x="685800" y="502920"/>
+            <a:ext cx="1005840" cy="1005840"/>
+          </a:xfrm>
+          <a:prstGeom prst="rect">
+            <a:avLst/>
+          </a:prstGeom>
+        </p:spPr>
+      </p:pic>
+      <p:sp>
+        <p:nvSpPr>
+          <p:cNvPr id="4" name="TextBox 3"/>
           <p:cNvSpPr txBox="1"/>
           <p:nvPr/>
         </p:nvSpPr>
         <p:spPr>
           <a:xfrm>
-            <a:off x="449784" y="746314"/>
-            <a:ext cx="8432950" cy="584775"/>
+            <a:off x="1828800" y="594360"/>
+            <a:ext cx="6858000" cy="457200"/>
           </a:xfrm>
           <a:prstGeom prst="rect">
             <a:avLst/>
@@ -3172,31 +3193,29 @@
           <a:lstStyle/>
           <a:p>
             <a:pPr>
-              <a:defRPr sz="3200" b="1">
-                <a:solidFill>
-                  <a:srgbClr val="FFFFFF"/>
-                </a:solidFill>
-                <a:latin typeface="Calibri"/>
-              </a:defRPr>
-            </a:pPr>
-            <a:r>
-              <a:rPr lang="en-US" dirty="0"/>
-              <a:t>Mantra AI Talent Accelarator Internship Program</a:t>
-            </a:r>
-            <a:endParaRPr dirty="0"/>
-          </a:p>
-        </p:txBody>
-      </p:sp>
-      <p:sp>
-        <p:nvSpPr>
-          <p:cNvPr id="6" name="TextBox 5"/>
+              <a:defRPr sz="1600" b="1">
+                <a:solidFill>
+                  <a:srgbClr val="22D3EE"/>
+                </a:solidFill>
+                <a:latin typeface="Calibri"/>
+              </a:defRPr>
+            </a:pPr>
+            <a:r>
+              <a:t>AI NextGen Industry Readiness Internship Program</a:t>
+            </a:r>
+          </a:p>
+        </p:txBody>
+      </p:sp>
+      <p:sp>
+        <p:nvSpPr>
+          <p:cNvPr id="5" name="TextBox 4"/>
           <p:cNvSpPr txBox="1"/>
           <p:nvPr/>
         </p:nvSpPr>
         <p:spPr>
           <a:xfrm>
-            <a:off x="685800" y="1965960"/>
-            <a:ext cx="8046720" cy="411480"/>
+            <a:off x="502920" y="1325880"/>
+            <a:ext cx="8229600" cy="685800"/>
           </a:xfrm>
           <a:prstGeom prst="rect">
             <a:avLst/>
@@ -3210,6 +3229,42 @@
           <a:lstStyle/>
           <a:p>
             <a:pPr>
+              <a:defRPr sz="3200" b="1">
+                <a:solidFill>
+                  <a:srgbClr val="FFFFFF"/>
+                </a:solidFill>
+                <a:latin typeface="Calibri"/>
+              </a:defRPr>
+            </a:pPr>
+            <a:r>
+              <a:t>Company Background &amp; Vision</a:t>
+            </a:r>
+          </a:p>
+        </p:txBody>
+      </p:sp>
+      <p:sp>
+        <p:nvSpPr>
+          <p:cNvPr id="6" name="TextBox 5"/>
+          <p:cNvSpPr txBox="1"/>
+          <p:nvPr/>
+        </p:nvSpPr>
+        <p:spPr>
+          <a:xfrm>
+            <a:off x="685800" y="1965960"/>
+            <a:ext cx="8046720" cy="411480"/>
+          </a:xfrm>
+          <a:prstGeom prst="rect">
+            <a:avLst/>
+          </a:prstGeom>
+          <a:noFill/>
+        </p:spPr>
+        <p:txBody>
+          <a:bodyPr wrap="none">
+            <a:spAutoFit/>
+          </a:bodyPr>
+          <a:lstStyle/>
+          <a:p>
+            <a:pPr>
               <a:defRPr sz="1500">
                 <a:solidFill>
                   <a:srgbClr val="7DD3FC"/>
@@ -3218,7 +3273,6 @@
               </a:defRPr>
             </a:pPr>
             <a:r>
-              <a:rPr dirty="0"/>
               <a:t>Transforming Students into Industry-Ready Professionals</a:t>
             </a:r>
           </a:p>
@@ -3233,7 +3287,7 @@
         <p:spPr>
           <a:xfrm>
             <a:off x="685800" y="2514600"/>
-            <a:ext cx="8046720" cy="1323439"/>
+            <a:ext cx="8046720" cy="1828800"/>
           </a:xfrm>
           <a:prstGeom prst="rect">
             <a:avLst/>
@@ -3258,16 +3312,7 @@
               </a:defRPr>
             </a:pPr>
             <a:r>
-              <a:rPr dirty="0"/>
-              <a:t>• 13+ years of IT industry experience — founded our </a:t>
-            </a:r>
-            <a:r>
-              <a:rPr lang="en-US" dirty="0"/>
-              <a:t>IT Services</a:t>
-            </a:r>
-            <a:r>
-              <a:rPr dirty="0"/>
-              <a:t> to bridge academic learning and real-world expectations</a:t>
+              <a:t>• 13+ years of IT industry experience — founded our startup to bridge academic learning and real-world expectations</a:t>
             </a:r>
           </a:p>
           <a:p>
@@ -3283,7 +3328,6 @@
               </a:defRPr>
             </a:pPr>
             <a:r>
-              <a:rPr dirty="0"/>
               <a:t>• Deep technical expertise serving clients across the United States</a:t>
             </a:r>
           </a:p>
@@ -3300,7 +3344,6 @@
               </a:defRPr>
             </a:pPr>
             <a:r>
-              <a:rPr dirty="0"/>
               <a:t>• We understand the skills and competencies organizations seek in today's workforce</a:t>
             </a:r>
           </a:p>
@@ -3317,7 +3360,6 @@
               </a:defRPr>
             </a:pPr>
             <a:r>
-              <a:rPr dirty="0"/>
               <a:t>• Mission: Industry-partnered programs that transform students into job-ready professionals</a:t>
             </a:r>
           </a:p>
@@ -3331,7 +3373,7 @@
         </p:nvSpPr>
         <p:spPr>
           <a:xfrm>
-            <a:off x="594360" y="3909060"/>
+            <a:off x="685800" y="4434840"/>
             <a:ext cx="7955279" cy="868680"/>
           </a:xfrm>
           <a:prstGeom prst="roundRect">
@@ -3365,7 +3407,7 @@
           <a:lstStyle/>
           <a:p>
             <a:pPr>
-              <a:defRPr sz="1200" b="1">
+              <a:defRPr b="1" sz="1200">
                 <a:solidFill>
                   <a:srgbClr val="22D3EE"/>
                 </a:solidFill>
@@ -3398,7 +3440,7 @@
         </p:nvSpPr>
         <p:spPr>
           <a:xfrm>
-            <a:off x="640080" y="4919472"/>
+            <a:off x="685800" y="5440680"/>
             <a:ext cx="7955279" cy="777240"/>
           </a:xfrm>
           <a:prstGeom prst="roundRect">
@@ -3432,7 +3474,7 @@
           <a:lstStyle/>
           <a:p>
             <a:pPr>
-              <a:defRPr sz="1200" b="1">
+              <a:defRPr b="1" sz="1200">
                 <a:solidFill>
                   <a:srgbClr val="22D3EE"/>
                 </a:solidFill>
@@ -3465,7 +3507,7 @@
         </p:nvSpPr>
         <p:spPr>
           <a:xfrm>
-            <a:off x="502920" y="5920740"/>
+            <a:off x="640080" y="5532120"/>
             <a:ext cx="1828800" cy="502920"/>
           </a:xfrm>
           <a:prstGeom prst="roundRect">
@@ -3518,7 +3560,7 @@
         </p:nvSpPr>
         <p:spPr>
           <a:xfrm>
-            <a:off x="2331720" y="6089904"/>
+            <a:off x="2496311" y="5696712"/>
             <a:ext cx="164592" cy="182880"/>
           </a:xfrm>
           <a:prstGeom prst="rightArrow">
@@ -3550,7 +3592,6 @@
           <a:lstStyle/>
           <a:p>
             <a:pPr algn="ctr"/>
-            <a:endParaRPr/>
           </a:p>
         </p:txBody>
       </p:sp>
@@ -3562,7 +3603,7 @@
         </p:nvSpPr>
         <p:spPr>
           <a:xfrm>
-            <a:off x="2514600" y="5964797"/>
+            <a:off x="2606039" y="5532120"/>
             <a:ext cx="1828800" cy="502920"/>
           </a:xfrm>
           <a:prstGeom prst="roundRect">
@@ -3615,7 +3656,7 @@
         </p:nvSpPr>
         <p:spPr>
           <a:xfrm>
-            <a:off x="4361688" y="6126777"/>
+            <a:off x="4462272" y="5696712"/>
             <a:ext cx="164592" cy="182880"/>
           </a:xfrm>
           <a:prstGeom prst="rightArrow">
@@ -3647,7 +3688,6 @@
           <a:lstStyle/>
           <a:p>
             <a:pPr algn="ctr"/>
-            <a:endParaRPr/>
           </a:p>
         </p:txBody>
       </p:sp>
@@ -3659,7 +3699,7 @@
         </p:nvSpPr>
         <p:spPr>
           <a:xfrm>
-            <a:off x="4571999" y="5964797"/>
+            <a:off x="4572000" y="5532120"/>
             <a:ext cx="1828800" cy="502920"/>
           </a:xfrm>
           <a:prstGeom prst="roundRect">
@@ -3699,7 +3739,6 @@
               </a:defRPr>
             </a:pPr>
             <a:r>
-              <a:rPr dirty="0"/>
               <a:t>Job-Ready Talent</a:t>
             </a:r>
           </a:p>
@@ -3713,7 +3752,7 @@
         </p:nvSpPr>
         <p:spPr>
           <a:xfrm>
-            <a:off x="6437375" y="6124817"/>
+            <a:off x="6428232" y="5696712"/>
             <a:ext cx="164592" cy="182880"/>
           </a:xfrm>
           <a:prstGeom prst="rightArrow">
@@ -3745,7 +3784,6 @@
           <a:lstStyle/>
           <a:p>
             <a:pPr algn="ctr"/>
-            <a:endParaRPr/>
           </a:p>
         </p:txBody>
       </p:sp>
@@ -3757,7 +3795,7 @@
         </p:nvSpPr>
         <p:spPr>
           <a:xfrm>
-            <a:off x="6601967" y="5989320"/>
+            <a:off x="6537959" y="5532120"/>
             <a:ext cx="1828800" cy="502920"/>
           </a:xfrm>
           <a:prstGeom prst="roundRect">
@@ -3802,45 +3840,6 @@
           </a:p>
         </p:txBody>
       </p:sp>
-      <p:sp>
-        <p:nvSpPr>
-          <p:cNvPr id="17" name="TextBox 16">
-            <a:extLst>
-              <a:ext uri="{FF2B5EF4-FFF2-40B4-BE49-F238E27FC236}">
-                <a16:creationId xmlns:a16="http://schemas.microsoft.com/office/drawing/2014/main" id="{92431972-4272-D8F7-8973-EF54C843DBE6}"/>
-              </a:ext>
-            </a:extLst>
-          </p:cNvPr>
-          <p:cNvSpPr txBox="1"/>
-          <p:nvPr/>
-        </p:nvSpPr>
-        <p:spPr>
-          <a:xfrm>
-            <a:off x="640080" y="1579418"/>
-            <a:ext cx="5226330" cy="369332"/>
-          </a:xfrm>
-          <a:prstGeom prst="rect">
-            <a:avLst/>
-          </a:prstGeom>
-          <a:noFill/>
-        </p:spPr>
-        <p:txBody>
-          <a:bodyPr wrap="square" rtlCol="0">
-            <a:spAutoFit/>
-          </a:bodyPr>
-          <a:lstStyle/>
-          <a:p>
-            <a:r>
-              <a:rPr lang="en-US" b="1" dirty="0">
-                <a:solidFill>
-                  <a:schemeClr val="bg1"/>
-                </a:solidFill>
-              </a:rPr>
-              <a:t>Company Vision</a:t>
-            </a:r>
-          </a:p>
-        </p:txBody>
-      </p:sp>
     </p:spTree>
   </p:cSld>
   <p:clrMapOvr>
@@ -3850,7 +3849,7 @@
 </file>
 
 <file path=ppt/slides/slide2.xml><?xml version="1.0" encoding="utf-8"?>
-<p:sld xmlns:a="http://schemas.openxmlformats.org/drawingml/2006/main" xmlns:r="http://schemas.openxmlformats.org/officeDocument/2006/relationships" xmlns:p="http://schemas.openxmlformats.org/presentationml/2006/main">
+<p:sld xmlns:a="http://schemas.openxmlformats.org/drawingml/2006/main" xmlns:p="http://schemas.openxmlformats.org/presentationml/2006/main" xmlns:r="http://schemas.openxmlformats.org/officeDocument/2006/relationships">
   <p:cSld>
     <p:bg>
       <p:bgPr>
@@ -3866,14 +3865,7 @@
         <p:cNvGrpSpPr/>
         <p:nvPr/>
       </p:nvGrpSpPr>
-      <p:grpSpPr>
-        <a:xfrm>
-          <a:off x="0" y="0"/>
-          <a:ext cx="0" cy="0"/>
-          <a:chOff x="0" y="0"/>
-          <a:chExt cx="0" cy="0"/>
-        </a:xfrm>
-      </p:grpSpPr>
+      <p:grpSpPr/>
       <p:sp>
         <p:nvSpPr>
           <p:cNvPr id="2" name="Rectangle 1"/>
@@ -3914,7 +3906,6 @@
           <a:lstStyle/>
           <a:p>
             <a:pPr algn="ctr"/>
-            <a:endParaRPr/>
           </a:p>
         </p:txBody>
       </p:sp>
@@ -3992,7 +3983,7 @@
           </a:fontRef>
         </p:style>
         <p:txBody>
-          <a:bodyPr wrap="square" rtlCol="0" anchor="ctr"/>
+          <a:bodyPr rtlCol="0" anchor="ctr" wrap="square"/>
           <a:lstStyle/>
           <a:p>
             <a:pPr>
@@ -4004,7 +3995,6 @@
               </a:defRPr>
             </a:pPr>
             <a:r>
-              <a:rPr sz="1600" dirty="0"/>
               <a:t>Through industry engagements and hiring, we observed a significant disconnect: graduates have theoretical knowledge but lack hands-on experience, industry exposure, and professional readiness for competitive work environments.</a:t>
             </a:r>
           </a:p>
@@ -4048,11 +4038,11 @@
           </a:fontRef>
         </p:style>
         <p:txBody>
-          <a:bodyPr wrap="square" lIns="127000" tIns="101600" rIns="127000" rtlCol="0" anchor="ctr"/>
+          <a:bodyPr rtlCol="0" anchor="ctr" wrap="square" lIns="127000" rIns="127000" tIns="101600"/>
           <a:lstStyle/>
           <a:p>
             <a:pPr algn="ctr">
-              <a:defRPr sz="1200" b="1">
+              <a:defRPr b="1" sz="1200">
                 <a:solidFill>
                   <a:srgbClr val="0B1A3A"/>
                 </a:solidFill>
@@ -4060,7 +4050,6 @@
               </a:defRPr>
             </a:pPr>
             <a:r>
-              <a:rPr sz="1400" dirty="0"/>
               <a:t>Student Challenges</a:t>
             </a:r>
           </a:p>
@@ -4077,7 +4066,6 @@
               </a:defRPr>
             </a:pPr>
             <a:r>
-              <a:rPr sz="1400" dirty="0"/>
               <a:t>Strong theory, limited practical exposure</a:t>
             </a:r>
           </a:p>
@@ -4094,7 +4082,6 @@
               </a:defRPr>
             </a:pPr>
             <a:r>
-              <a:rPr sz="1400" dirty="0"/>
               <a:t>No real-world project experience</a:t>
             </a:r>
           </a:p>
@@ -4111,7 +4098,6 @@
               </a:defRPr>
             </a:pPr>
             <a:r>
-              <a:rPr sz="1400" dirty="0"/>
               <a:t>Limited industry workflow understanding</a:t>
             </a:r>
           </a:p>
@@ -4128,7 +4114,6 @@
               </a:defRPr>
             </a:pPr>
             <a:r>
-              <a:rPr sz="1400" dirty="0"/>
               <a:t>Communication &amp; interview readiness gaps</a:t>
             </a:r>
           </a:p>
@@ -4145,7 +4130,6 @@
               </a:defRPr>
             </a:pPr>
             <a:r>
-              <a:rPr sz="1400" dirty="0"/>
               <a:t>Hard transition from classroom to workplace</a:t>
             </a:r>
           </a:p>
@@ -4189,11 +4173,11 @@
           </a:fontRef>
         </p:style>
         <p:txBody>
-          <a:bodyPr wrap="square" lIns="127000" tIns="101600" rIns="127000" rtlCol="0" anchor="ctr"/>
+          <a:bodyPr rtlCol="0" anchor="ctr" wrap="square" lIns="127000" rIns="127000" tIns="101600"/>
           <a:lstStyle/>
           <a:p>
             <a:pPr algn="ctr">
-              <a:defRPr sz="1200" b="1">
+              <a:defRPr b="1" sz="1200">
                 <a:solidFill>
                   <a:srgbClr val="0B1A3A"/>
                 </a:solidFill>
@@ -4201,7 +4185,6 @@
               </a:defRPr>
             </a:pPr>
             <a:r>
-              <a:rPr sz="1400" dirty="0"/>
               <a:t>College Challenges</a:t>
             </a:r>
           </a:p>
@@ -4218,7 +4201,6 @@
               </a:defRPr>
             </a:pPr>
             <a:r>
-              <a:rPr sz="1400" dirty="0"/>
               <a:t>Rising placement expectations from management</a:t>
             </a:r>
           </a:p>
@@ -4235,7 +4217,6 @@
               </a:defRPr>
             </a:pPr>
             <a:r>
-              <a:rPr sz="1400" dirty="0"/>
               <a:t>Rapidly changing technology landscape</a:t>
             </a:r>
           </a:p>
@@ -4252,7 +4233,6 @@
               </a:defRPr>
             </a:pPr>
             <a:r>
-              <a:rPr sz="1400" dirty="0"/>
               <a:t>Industry–academia skill mismatch</a:t>
             </a:r>
           </a:p>
@@ -4269,7 +4249,6 @@
               </a:defRPr>
             </a:pPr>
             <a:r>
-              <a:rPr sz="1400" dirty="0"/>
               <a:t>Need for measurable employability outcomes</a:t>
             </a:r>
           </a:p>
@@ -4286,7 +4265,6 @@
               </a:defRPr>
             </a:pPr>
             <a:r>
-              <a:rPr sz="1400" dirty="0"/>
               <a:t>Faculty bandwidth for 500+ students</a:t>
             </a:r>
           </a:p>
@@ -4339,7 +4317,6 @@
               </a:defRPr>
             </a:pPr>
             <a:r>
-              <a:rPr dirty="0"/>
               <a:t>College Education  ←—— GAP ——→  Industry Expectations</a:t>
             </a:r>
           </a:p>
@@ -4354,7 +4331,7 @@
 </file>
 
 <file path=ppt/slides/slide3.xml><?xml version="1.0" encoding="utf-8"?>
-<p:sld xmlns:a="http://schemas.openxmlformats.org/drawingml/2006/main" xmlns:r="http://schemas.openxmlformats.org/officeDocument/2006/relationships" xmlns:p="http://schemas.openxmlformats.org/presentationml/2006/main">
+<p:sld xmlns:a="http://schemas.openxmlformats.org/drawingml/2006/main" xmlns:p="http://schemas.openxmlformats.org/presentationml/2006/main" xmlns:r="http://schemas.openxmlformats.org/officeDocument/2006/relationships">
   <p:cSld>
     <p:bg>
       <p:bgPr>
@@ -4370,14 +4347,7 @@
         <p:cNvGrpSpPr/>
         <p:nvPr/>
       </p:nvGrpSpPr>
-      <p:grpSpPr>
-        <a:xfrm>
-          <a:off x="0" y="0"/>
-          <a:ext cx="0" cy="0"/>
-          <a:chOff x="0" y="0"/>
-          <a:chExt cx="0" cy="0"/>
-        </a:xfrm>
-      </p:grpSpPr>
+      <p:grpSpPr/>
       <p:sp>
         <p:nvSpPr>
           <p:cNvPr id="2" name="Rectangle 1"/>
@@ -4418,7 +4388,6 @@
           <a:lstStyle/>
           <a:p>
             <a:pPr algn="ctr"/>
-            <a:endParaRPr/>
           </a:p>
         </p:txBody>
       </p:sp>
@@ -4467,7 +4436,7 @@
         <p:spPr>
           <a:xfrm>
             <a:off x="502920" y="1024128"/>
-            <a:ext cx="8138160" cy="523220"/>
+            <a:ext cx="8138160" cy="502920"/>
           </a:xfrm>
           <a:prstGeom prst="rect">
             <a:avLst/>
@@ -4489,7 +4458,6 @@
               </a:defRPr>
             </a:pPr>
             <a:r>
-              <a:rPr sz="1400" dirty="0"/>
               <a:t>Industry-partnered internship program: real-world projects, mentorship from experienced IT professionals, practical technical training, and industry best practices.</a:t>
             </a:r>
           </a:p>
@@ -4585,11 +4553,11 @@
           </a:fontRef>
         </p:style>
         <p:txBody>
-          <a:bodyPr wrap="square" lIns="127000" tIns="101600" rIns="127000" rtlCol="0" anchor="ctr"/>
+          <a:bodyPr rtlCol="0" anchor="ctr" wrap="square" lIns="127000" rIns="127000" tIns="101600"/>
           <a:lstStyle/>
           <a:p>
             <a:pPr algn="ctr">
-              <a:defRPr sz="1200" b="1">
+              <a:defRPr b="1" sz="1200">
                 <a:solidFill>
                   <a:srgbClr val="0B1A3A"/>
                 </a:solidFill>
@@ -4597,7 +4565,6 @@
               </a:defRPr>
             </a:pPr>
             <a:r>
-              <a:rPr sz="1600" dirty="0"/>
               <a:t>Technical Skill Development</a:t>
             </a:r>
           </a:p>
@@ -4614,14 +4581,10 @@
               </a:defRPr>
             </a:pPr>
             <a:r>
-              <a:rPr sz="1100" dirty="0"/>
               <a:t>Python · Full Stack · AI tracks</a:t>
             </a:r>
-            <a:br>
-              <a:rPr sz="1100" dirty="0"/>
-            </a:br>
-            <a:r>
-              <a:rPr sz="1100" dirty="0"/>
+            <a:br/>
+            <a:r>
               <a:t>200+ lessons · live coding labs</a:t>
             </a:r>
           </a:p>
@@ -4717,11 +4680,11 @@
           </a:fontRef>
         </p:style>
         <p:txBody>
-          <a:bodyPr wrap="square" lIns="127000" tIns="101600" rIns="127000" rtlCol="0" anchor="ctr"/>
+          <a:bodyPr rtlCol="0" anchor="ctr" wrap="square" lIns="127000" rIns="127000" tIns="101600"/>
           <a:lstStyle/>
           <a:p>
             <a:pPr algn="ctr">
-              <a:defRPr sz="1200" b="1">
+              <a:defRPr b="1" sz="1200">
                 <a:solidFill>
                   <a:srgbClr val="0B1A3A"/>
                 </a:solidFill>
@@ -4729,7 +4692,6 @@
               </a:defRPr>
             </a:pPr>
             <a:r>
-              <a:rPr sz="1600" dirty="0"/>
               <a:t>Hands-on Project Experience</a:t>
             </a:r>
           </a:p>
@@ -4746,7 +4708,6 @@
               </a:defRPr>
             </a:pPr>
             <a:r>
-              <a:rPr sz="1100" dirty="0"/>
               <a:t>Mini projects · capstone · GitHub portfolio</a:t>
             </a:r>
           </a:p>
@@ -4842,11 +4803,11 @@
           </a:fontRef>
         </p:style>
         <p:txBody>
-          <a:bodyPr wrap="square" lIns="127000" tIns="101600" rIns="127000" rtlCol="0" anchor="ctr"/>
+          <a:bodyPr rtlCol="0" anchor="ctr" wrap="square" lIns="127000" rIns="127000" tIns="101600"/>
           <a:lstStyle/>
           <a:p>
             <a:pPr algn="ctr">
-              <a:defRPr sz="1200" b="1">
+              <a:defRPr b="1" sz="1200">
                 <a:solidFill>
                   <a:srgbClr val="0B1A3A"/>
                 </a:solidFill>
@@ -4854,7 +4815,6 @@
               </a:defRPr>
             </a:pPr>
             <a:r>
-              <a:rPr sz="1600" dirty="0"/>
               <a:t>Industry Mentorship</a:t>
             </a:r>
           </a:p>
@@ -4871,7 +4831,6 @@
               </a:defRPr>
             </a:pPr>
             <a:r>
-              <a:rPr sz="1100" dirty="0"/>
               <a:t>Weekly live sessions · recorded Q&amp;A · mentor feedback</a:t>
             </a:r>
           </a:p>
@@ -4967,11 +4926,11 @@
           </a:fontRef>
         </p:style>
         <p:txBody>
-          <a:bodyPr wrap="square" lIns="127000" tIns="101600" rIns="127000" rtlCol="0" anchor="ctr"/>
+          <a:bodyPr rtlCol="0" anchor="ctr" wrap="square" lIns="127000" rIns="127000" tIns="101600"/>
           <a:lstStyle/>
           <a:p>
             <a:pPr algn="ctr">
-              <a:defRPr sz="1200" b="1">
+              <a:defRPr b="1" sz="1200">
                 <a:solidFill>
                   <a:srgbClr val="0B1A3A"/>
                 </a:solidFill>
@@ -4979,7 +4938,6 @@
               </a:defRPr>
             </a:pPr>
             <a:r>
-              <a:rPr sz="1600" dirty="0"/>
               <a:t>Career Readiness Training</a:t>
             </a:r>
           </a:p>
@@ -4996,7 +4954,6 @@
               </a:defRPr>
             </a:pPr>
             <a:r>
-              <a:rPr sz="1100" dirty="0"/>
               <a:t>Interview prep · HR modules · mock dialogues</a:t>
             </a:r>
           </a:p>
@@ -5092,11 +5049,11 @@
           </a:fontRef>
         </p:style>
         <p:txBody>
-          <a:bodyPr wrap="square" lIns="127000" tIns="101600" rIns="127000" rtlCol="0" anchor="ctr"/>
+          <a:bodyPr rtlCol="0" anchor="ctr" wrap="square" lIns="127000" rIns="127000" tIns="101600"/>
           <a:lstStyle/>
           <a:p>
             <a:pPr algn="ctr">
-              <a:defRPr sz="1200" b="1">
+              <a:defRPr b="1" sz="1200">
                 <a:solidFill>
                   <a:srgbClr val="0B1A3A"/>
                 </a:solidFill>
@@ -5104,7 +5061,6 @@
               </a:defRPr>
             </a:pPr>
             <a:r>
-              <a:rPr sz="1600" dirty="0"/>
               <a:t>Assessment &amp; Tracking</a:t>
             </a:r>
           </a:p>
@@ -5121,7 +5077,6 @@
               </a:defRPr>
             </a:pPr>
             <a:r>
-              <a:rPr sz="1100" dirty="0"/>
               <a:t>50-Q weekly quizzes · XP · leaderboard · analytics</a:t>
             </a:r>
           </a:p>
@@ -5217,11 +5172,11 @@
           </a:fontRef>
         </p:style>
         <p:txBody>
-          <a:bodyPr wrap="square" lIns="127000" tIns="101600" rIns="127000" rtlCol="0" anchor="ctr"/>
+          <a:bodyPr rtlCol="0" anchor="ctr" wrap="square" lIns="127000" rIns="127000" tIns="101600"/>
           <a:lstStyle/>
           <a:p>
             <a:pPr algn="ctr">
-              <a:defRPr sz="1200" b="1">
+              <a:defRPr b="1" sz="1200">
                 <a:solidFill>
                   <a:srgbClr val="0B1A3A"/>
                 </a:solidFill>
@@ -5229,7 +5184,6 @@
               </a:defRPr>
             </a:pPr>
             <a:r>
-              <a:rPr sz="1600" dirty="0"/>
               <a:t>Placement Preparation</a:t>
             </a:r>
           </a:p>
@@ -5246,8 +5200,7 @@
               </a:defRPr>
             </a:pPr>
             <a:r>
-              <a:rPr sz="1100" dirty="0"/>
-              <a:t>coding · resume · employer connect</a:t>
+              <a:t>Aptitude · coding · resume · employer connect</a:t>
             </a:r>
           </a:p>
         </p:txBody>
@@ -5299,7 +5252,6 @@
               </a:defRPr>
             </a:pPr>
             <a:r>
-              <a:rPr sz="1600" dirty="0"/>
               <a:t>Our Impact</a:t>
             </a:r>
           </a:p>
@@ -5312,7 +5264,6 @@
               </a:defRPr>
             </a:pPr>
             <a:r>
-              <a:rPr sz="1400" dirty="0"/>
               <a:t>Industry-ready graduates with practical knowledge, portfolio proof, and confidence — prepared to thrive in modern organizations from day one.</a:t>
             </a:r>
           </a:p>
@@ -5327,7 +5278,7 @@
 </file>
 
 <file path=ppt/slides/slide4.xml><?xml version="1.0" encoding="utf-8"?>
-<p:sld xmlns:a="http://schemas.openxmlformats.org/drawingml/2006/main" xmlns:r="http://schemas.openxmlformats.org/officeDocument/2006/relationships" xmlns:p="http://schemas.openxmlformats.org/presentationml/2006/main">
+<p:sld xmlns:a="http://schemas.openxmlformats.org/drawingml/2006/main" xmlns:p="http://schemas.openxmlformats.org/presentationml/2006/main" xmlns:r="http://schemas.openxmlformats.org/officeDocument/2006/relationships">
   <p:cSld>
     <p:bg>
       <p:bgPr>
@@ -5343,14 +5294,7 @@
         <p:cNvGrpSpPr/>
         <p:nvPr/>
       </p:nvGrpSpPr>
-      <p:grpSpPr>
-        <a:xfrm>
-          <a:off x="0" y="0"/>
-          <a:ext cx="0" cy="0"/>
-          <a:chOff x="0" y="0"/>
-          <a:chExt cx="0" cy="0"/>
-        </a:xfrm>
-      </p:grpSpPr>
+      <p:grpSpPr/>
       <p:sp>
         <p:nvSpPr>
           <p:cNvPr id="2" name="Rectangle 1"/>
@@ -5391,7 +5335,6 @@
           <a:lstStyle/>
           <a:p>
             <a:pPr algn="ctr"/>
-            <a:endParaRPr/>
           </a:p>
         </p:txBody>
       </p:sp>
@@ -5471,7 +5414,6 @@
           <a:lstStyle/>
           <a:p>
             <a:pPr algn="ctr"/>
-            <a:endParaRPr/>
           </a:p>
         </p:txBody>
       </p:sp>
@@ -5515,7 +5457,6 @@
           <a:lstStyle/>
           <a:p>
             <a:pPr algn="ctr"/>
-            <a:endParaRPr/>
           </a:p>
         </p:txBody>
       </p:sp>
@@ -5557,11 +5498,11 @@
           </a:fontRef>
         </p:style>
         <p:txBody>
-          <a:bodyPr wrap="square" lIns="127000" tIns="101600" rIns="127000" rtlCol="0" anchor="ctr"/>
+          <a:bodyPr rtlCol="0" anchor="ctr" wrap="square" lIns="127000" rIns="127000" tIns="101600"/>
           <a:lstStyle/>
           <a:p>
             <a:pPr algn="ctr">
-              <a:defRPr sz="1200" b="1">
+              <a:defRPr b="1" sz="1200">
                 <a:solidFill>
                   <a:srgbClr val="0B1A3A"/>
                 </a:solidFill>
@@ -5569,12 +5510,6 @@
               </a:defRPr>
             </a:pPr>
             <a:r>
-              <a:rPr sz="1600" b="1" dirty="0">
-                <a:solidFill>
-                  <a:srgbClr val="0B1A3A"/>
-                </a:solidFill>
-                <a:latin typeface="Calibri"/>
-              </a:rPr>
               <a:t>Phase 1: Foundation Skills</a:t>
             </a:r>
           </a:p>
@@ -5591,7 +5526,6 @@
               </a:defRPr>
             </a:pPr>
             <a:r>
-              <a:rPr sz="1100" dirty="0"/>
               <a:t>Programming · Databases · APIs · Git · Linux · Debugging</a:t>
             </a:r>
           </a:p>
@@ -5637,7 +5571,6 @@
           <a:lstStyle/>
           <a:p>
             <a:pPr algn="ctr"/>
-            <a:endParaRPr/>
           </a:p>
         </p:txBody>
       </p:sp>
@@ -5681,7 +5614,6 @@
           <a:lstStyle/>
           <a:p>
             <a:pPr algn="ctr"/>
-            <a:endParaRPr/>
           </a:p>
         </p:txBody>
       </p:sp>
@@ -5725,7 +5657,6 @@
           <a:lstStyle/>
           <a:p>
             <a:pPr algn="ctr"/>
-            <a:endParaRPr/>
           </a:p>
         </p:txBody>
       </p:sp>
@@ -5767,11 +5698,11 @@
           </a:fontRef>
         </p:style>
         <p:txBody>
-          <a:bodyPr wrap="square" lIns="127000" tIns="101600" rIns="127000" rtlCol="0" anchor="ctr"/>
+          <a:bodyPr rtlCol="0" anchor="ctr" wrap="square" lIns="127000" rIns="127000" tIns="101600"/>
           <a:lstStyle/>
           <a:p>
             <a:pPr algn="ctr">
-              <a:defRPr sz="1200" b="1">
+              <a:defRPr b="1" sz="1200">
                 <a:solidFill>
                   <a:srgbClr val="0B1A3A"/>
                 </a:solidFill>
@@ -5779,7 +5710,6 @@
               </a:defRPr>
             </a:pPr>
             <a:r>
-              <a:rPr sz="1600" dirty="0"/>
               <a:t>Phase 2: Project Development</a:t>
             </a:r>
           </a:p>
@@ -5796,7 +5726,6 @@
               </a:defRPr>
             </a:pPr>
             <a:r>
-              <a:rPr sz="1100" dirty="0"/>
               <a:t>Team projects · Agile · Code reviews · Real-world use cases</a:t>
             </a:r>
           </a:p>
@@ -5842,7 +5771,6 @@
           <a:lstStyle/>
           <a:p>
             <a:pPr algn="ctr"/>
-            <a:endParaRPr/>
           </a:p>
         </p:txBody>
       </p:sp>
@@ -5886,7 +5814,6 @@
           <a:lstStyle/>
           <a:p>
             <a:pPr algn="ctr"/>
-            <a:endParaRPr/>
           </a:p>
         </p:txBody>
       </p:sp>
@@ -5930,7 +5857,6 @@
           <a:lstStyle/>
           <a:p>
             <a:pPr algn="ctr"/>
-            <a:endParaRPr/>
           </a:p>
         </p:txBody>
       </p:sp>
@@ -5972,11 +5898,11 @@
           </a:fontRef>
         </p:style>
         <p:txBody>
-          <a:bodyPr wrap="square" lIns="127000" tIns="101600" rIns="127000" rtlCol="0" anchor="ctr"/>
+          <a:bodyPr rtlCol="0" anchor="ctr" wrap="square" lIns="127000" rIns="127000" tIns="101600"/>
           <a:lstStyle/>
           <a:p>
             <a:pPr algn="ctr">
-              <a:defRPr sz="1200" b="1">
+              <a:defRPr b="1" sz="1200">
                 <a:solidFill>
                   <a:srgbClr val="0B1A3A"/>
                 </a:solidFill>
@@ -5984,7 +5910,6 @@
               </a:defRPr>
             </a:pPr>
             <a:r>
-              <a:rPr sz="1600" dirty="0"/>
               <a:t>Phase 3: Industry Simulation</a:t>
             </a:r>
           </a:p>
@@ -6001,7 +5926,6 @@
               </a:defRPr>
             </a:pPr>
             <a:r>
-              <a:rPr sz="1100" dirty="0"/>
               <a:t>Professional workflows · Documentation · Collaboration</a:t>
             </a:r>
           </a:p>
@@ -6047,7 +5971,6 @@
           <a:lstStyle/>
           <a:p>
             <a:pPr algn="ctr"/>
-            <a:endParaRPr/>
           </a:p>
         </p:txBody>
       </p:sp>
@@ -6091,7 +6014,6 @@
           <a:lstStyle/>
           <a:p>
             <a:pPr algn="ctr"/>
-            <a:endParaRPr/>
           </a:p>
         </p:txBody>
       </p:sp>
@@ -6135,7 +6057,6 @@
           <a:lstStyle/>
           <a:p>
             <a:pPr algn="ctr"/>
-            <a:endParaRPr/>
           </a:p>
         </p:txBody>
       </p:sp>
@@ -6177,11 +6098,11 @@
           </a:fontRef>
         </p:style>
         <p:txBody>
-          <a:bodyPr wrap="square" lIns="127000" tIns="101600" rIns="127000" rtlCol="0" anchor="ctr"/>
+          <a:bodyPr rtlCol="0" anchor="ctr" wrap="square" lIns="127000" rIns="127000" tIns="101600"/>
           <a:lstStyle/>
           <a:p>
             <a:pPr algn="ctr">
-              <a:defRPr sz="1200" b="1">
+              <a:defRPr b="1" sz="1200">
                 <a:solidFill>
                   <a:srgbClr val="0B1A3A"/>
                 </a:solidFill>
@@ -6189,7 +6110,6 @@
               </a:defRPr>
             </a:pPr>
             <a:r>
-              <a:rPr sz="1600" dirty="0"/>
               <a:t>Phase 4: Performance Evaluation</a:t>
             </a:r>
           </a:p>
@@ -6206,7 +6126,6 @@
               </a:defRPr>
             </a:pPr>
             <a:r>
-              <a:rPr sz="1100" dirty="0"/>
               <a:t>Weekly assessments · Feedback · Progress dashboards</a:t>
             </a:r>
           </a:p>
@@ -6254,14 +6173,13 @@
           <a:lstStyle/>
           <a:p>
             <a:pPr>
-              <a:defRPr sz="1400" b="1">
+              <a:defRPr b="1" sz="1400">
                 <a:solidFill>
                   <a:srgbClr val="0B1A3A"/>
                 </a:solidFill>
               </a:defRPr>
             </a:pPr>
             <a:r>
-              <a:rPr dirty="0"/>
               <a:t>Three Live Internship Tracks (8 Weeks Each)</a:t>
             </a:r>
           </a:p>
@@ -6274,24 +6192,7 @@
               </a:defRPr>
             </a:pPr>
             <a:r>
-              <a:rPr sz="1400" dirty="0"/>
-              <a:t>• Python Engineering Foundations — Linux, Git, </a:t>
-            </a:r>
-            <a:r>
-              <a:rPr sz="1400" dirty="0" err="1"/>
-              <a:t>DSA,</a:t>
-            </a:r>
-            <a:r>
-              <a:rPr lang="en-US" sz="1400" dirty="0" err="1"/>
-              <a:t>Core</a:t>
-            </a:r>
-            <a:r>
-              <a:rPr lang="en-US" sz="1400" dirty="0"/>
-              <a:t> Python,</a:t>
-            </a:r>
-            <a:r>
-              <a:rPr sz="1400" dirty="0"/>
-              <a:t> REST APIs, backend readiness</a:t>
+              <a:t>• Python Engineering Foundations — Linux, Git, DSA, REST APIs, backend readiness</a:t>
             </a:r>
           </a:p>
           <a:p>
@@ -6303,24 +6204,7 @@
               </a:defRPr>
             </a:pPr>
             <a:r>
-              <a:rPr sz="1400" dirty="0"/>
-              <a:t>• Full Stack Product Engineering — React, </a:t>
-            </a:r>
-            <a:r>
-              <a:rPr sz="1400" dirty="0" err="1"/>
-              <a:t>Next.js</a:t>
-            </a:r>
-            <a:r>
-              <a:rPr sz="1400" dirty="0"/>
-              <a:t>, </a:t>
-            </a:r>
-            <a:r>
-              <a:rPr sz="1400" dirty="0" err="1"/>
-              <a:t>NestJS</a:t>
-            </a:r>
-            <a:r>
-              <a:rPr sz="1400" dirty="0"/>
-              <a:t>, PostgreSQL, Docker, DevOps</a:t>
+              <a:t>• Full Stack Product Engineering — React, Next.js, NestJS, PostgreSQL, Docker, DevOps</a:t>
             </a:r>
           </a:p>
           <a:p>
@@ -6332,16 +6216,7 @@
               </a:defRPr>
             </a:pPr>
             <a:r>
-              <a:rPr sz="1400" dirty="0"/>
-              <a:t>• AI Engineering &amp; Intelligent Systems (Advanced) — LLMs, RAG, agents, </a:t>
-            </a:r>
-            <a:r>
-              <a:rPr sz="1400" dirty="0" err="1"/>
-              <a:t>FastAPI</a:t>
-            </a:r>
-            <a:r>
-              <a:rPr sz="1400" dirty="0"/>
-              <a:t>, vector DBs, AI UX</a:t>
+              <a:t>• AI Engineering &amp; Intelligent Systems (Advanced) — LLMs, RAG, agents, FastAPI, vector DBs, AI UX</a:t>
             </a:r>
           </a:p>
         </p:txBody>
@@ -6355,7 +6230,7 @@
 </file>
 
 <file path=ppt/slides/slide5.xml><?xml version="1.0" encoding="utf-8"?>
-<p:sld xmlns:a="http://schemas.openxmlformats.org/drawingml/2006/main" xmlns:r="http://schemas.openxmlformats.org/officeDocument/2006/relationships" xmlns:p="http://schemas.openxmlformats.org/presentationml/2006/main">
+<p:sld xmlns:a="http://schemas.openxmlformats.org/drawingml/2006/main" xmlns:p="http://schemas.openxmlformats.org/presentationml/2006/main" xmlns:r="http://schemas.openxmlformats.org/officeDocument/2006/relationships">
   <p:cSld>
     <p:bg>
       <p:bgPr>
@@ -6371,14 +6246,7 @@
         <p:cNvGrpSpPr/>
         <p:nvPr/>
       </p:nvGrpSpPr>
-      <p:grpSpPr>
-        <a:xfrm>
-          <a:off x="0" y="0"/>
-          <a:ext cx="0" cy="0"/>
-          <a:chOff x="0" y="0"/>
-          <a:chExt cx="0" cy="0"/>
-        </a:xfrm>
-      </p:grpSpPr>
+      <p:grpSpPr/>
       <p:sp>
         <p:nvSpPr>
           <p:cNvPr id="2" name="Rectangle 1"/>
@@ -6419,7 +6287,6 @@
           <a:lstStyle/>
           <a:p>
             <a:pPr algn="ctr"/>
-            <a:endParaRPr/>
           </a:p>
         </p:txBody>
       </p:sp>
@@ -6468,7 +6335,7 @@
         <p:spPr>
           <a:xfrm>
             <a:off x="502920" y="1143000"/>
-            <a:ext cx="4114800" cy="3431709"/>
+            <a:ext cx="4114800" cy="4114800"/>
           </a:xfrm>
           <a:prstGeom prst="rect">
             <a:avLst/>
@@ -6493,7 +6360,6 @@
               </a:defRPr>
             </a:pPr>
             <a:r>
-              <a:rPr sz="1600" dirty="0"/>
               <a:t>• Live project environments with browser-based coding sandbox</a:t>
             </a:r>
           </a:p>
@@ -6510,7 +6376,6 @@
               </a:defRPr>
             </a:pPr>
             <a:r>
-              <a:rPr sz="1600" dirty="0"/>
               <a:t>• Industry-standard tools: Git, Docker, REST APIs, cloud-ready stacks</a:t>
             </a:r>
           </a:p>
@@ -6527,16 +6392,7 @@
               </a:defRPr>
             </a:pPr>
             <a:r>
-              <a:rPr sz="1600" dirty="0"/>
-              <a:t>• Mentor-guided assignments with weekly </a:t>
-            </a:r>
-            <a:r>
-              <a:rPr lang="en-US" sz="1600" dirty="0"/>
-              <a:t>online</a:t>
-            </a:r>
-            <a:r>
-              <a:rPr sz="1600" dirty="0"/>
-              <a:t> sessions + recordings</a:t>
+              <a:t>• Mentor-guided assignments with weekly live sessions + recordings</a:t>
             </a:r>
           </a:p>
           <a:p>
@@ -6552,7 +6408,6 @@
               </a:defRPr>
             </a:pPr>
             <a:r>
-              <a:rPr sz="1600" dirty="0"/>
               <a:t>• Professional development: documentation, presentations, teamwork</a:t>
             </a:r>
           </a:p>
@@ -6569,7 +6424,6 @@
               </a:defRPr>
             </a:pPr>
             <a:r>
-              <a:rPr sz="1600" dirty="0"/>
               <a:t>• Client-centric problem solving through capstone &amp; hackathon</a:t>
             </a:r>
           </a:p>
@@ -6586,7 +6440,6 @@
               </a:defRPr>
             </a:pPr>
             <a:r>
-              <a:rPr sz="1600" dirty="0"/>
               <a:t>• 24/7 lesson-scoped AI tutor for continuous learning support</a:t>
             </a:r>
           </a:p>
@@ -6630,11 +6483,11 @@
           </a:fontRef>
         </p:style>
         <p:txBody>
-          <a:bodyPr wrap="square" lIns="127000" tIns="101600" rIns="127000" rtlCol="0" anchor="ctr"/>
+          <a:bodyPr rtlCol="0" anchor="ctr" wrap="square" lIns="127000" rIns="127000" tIns="101600"/>
           <a:lstStyle/>
           <a:p>
             <a:pPr algn="ctr">
-              <a:defRPr sz="1200" b="1">
+              <a:defRPr b="1" sz="1200">
                 <a:solidFill>
                   <a:srgbClr val="0B1A3A"/>
                 </a:solidFill>
@@ -6642,7 +6495,6 @@
               </a:defRPr>
             </a:pPr>
             <a:r>
-              <a:rPr sz="1600" dirty="0"/>
               <a:t>Student Deliverables</a:t>
             </a:r>
           </a:p>
@@ -6659,7 +6511,6 @@
               </a:defRPr>
             </a:pPr>
             <a:r>
-              <a:rPr sz="1600" dirty="0"/>
               <a:t>✓  Project Portfolio (GitHub repos)</a:t>
             </a:r>
           </a:p>
@@ -6676,7 +6527,6 @@
               </a:defRPr>
             </a:pPr>
             <a:r>
-              <a:rPr sz="1600" dirty="0"/>
               <a:t>✓  Technical Documentation</a:t>
             </a:r>
           </a:p>
@@ -6693,7 +6543,6 @@
               </a:defRPr>
             </a:pPr>
             <a:r>
-              <a:rPr sz="1600" dirty="0"/>
               <a:t>✓  Presentation &amp; Demo Skills</a:t>
             </a:r>
           </a:p>
@@ -6710,7 +6559,6 @@
               </a:defRPr>
             </a:pPr>
             <a:r>
-              <a:rPr sz="1600" dirty="0"/>
               <a:t>✓  QR-Verified Completion Certificate</a:t>
             </a:r>
           </a:p>
@@ -6727,39 +6575,8 @@
               </a:defRPr>
             </a:pPr>
             <a:r>
-              <a:rPr sz="1600" dirty="0"/>
-              <a:t>✓  Internship </a:t>
-            </a:r>
-            <a:r>
-              <a:rPr sz="1600" dirty="0" err="1"/>
-              <a:t>LoR</a:t>
-            </a:r>
-            <a:r>
-              <a:rPr sz="1600" dirty="0"/>
-              <a:t> </a:t>
-            </a:r>
-            <a:br>
-              <a:rPr lang="en-US" sz="1600" dirty="0"/>
-            </a:br>
-            <a:r>
-              <a:rPr sz="1600" dirty="0"/>
-              <a:t>✓  Hackathon participation certificate</a:t>
-            </a:r>
-            <a:br>
-              <a:rPr lang="en-US" sz="1600" dirty="0"/>
-            </a:br>
-            <a:r>
-              <a:rPr lang="en-IN" sz="1600" dirty="0"/>
-              <a:t>✓  Paid Internship(Merit-based)</a:t>
-            </a:r>
-            <a:br>
-              <a:rPr lang="en-IN" sz="1600" dirty="0"/>
-            </a:br>
-            <a:r>
-              <a:rPr lang="en-IN" sz="1600" dirty="0"/>
-              <a:t>✓  Placement Assurance</a:t>
-            </a:r>
-            <a:endParaRPr lang="en-US" sz="1600" dirty="0"/>
+              <a:t>✓  Internship LoR (merit-based)</a:t>
+            </a:r>
           </a:p>
           <a:p>
             <a:pPr>
@@ -6773,7 +6590,9 @@
                 <a:latin typeface="Calibri"/>
               </a:defRPr>
             </a:pPr>
-            <a:endParaRPr sz="1600" dirty="0"/>
+            <a:r>
+              <a:t>✓  Hackathon participation certificate</a:t>
+            </a:r>
           </a:p>
         </p:txBody>
       </p:sp>
@@ -6838,7 +6657,7 @@
 </file>
 
 <file path=ppt/slides/slide6.xml><?xml version="1.0" encoding="utf-8"?>
-<p:sld xmlns:a="http://schemas.openxmlformats.org/drawingml/2006/main" xmlns:r="http://schemas.openxmlformats.org/officeDocument/2006/relationships" xmlns:p="http://schemas.openxmlformats.org/presentationml/2006/main">
+<p:sld xmlns:a="http://schemas.openxmlformats.org/drawingml/2006/main" xmlns:p="http://schemas.openxmlformats.org/presentationml/2006/main" xmlns:r="http://schemas.openxmlformats.org/officeDocument/2006/relationships">
   <p:cSld>
     <p:bg>
       <p:bgPr>
@@ -6854,14 +6673,7 @@
         <p:cNvGrpSpPr/>
         <p:nvPr/>
       </p:nvGrpSpPr>
-      <p:grpSpPr>
-        <a:xfrm>
-          <a:off x="0" y="0"/>
-          <a:ext cx="0" cy="0"/>
-          <a:chOff x="0" y="0"/>
-          <a:chExt cx="0" cy="0"/>
-        </a:xfrm>
-      </p:grpSpPr>
+      <p:grpSpPr/>
       <p:sp>
         <p:nvSpPr>
           <p:cNvPr id="2" name="Rectangle 1"/>
@@ -6902,7 +6714,6 @@
           <a:lstStyle/>
           <a:p>
             <a:pPr algn="ctr"/>
-            <a:endParaRPr/>
           </a:p>
         </p:txBody>
       </p:sp>
@@ -6980,11 +6791,11 @@
           </a:fontRef>
         </p:style>
         <p:txBody>
-          <a:bodyPr wrap="square" lIns="127000" tIns="101600" rIns="127000" rtlCol="0" anchor="ctr"/>
+          <a:bodyPr rtlCol="0" anchor="ctr" wrap="square" lIns="127000" rIns="127000" tIns="101600"/>
           <a:lstStyle/>
           <a:p>
             <a:pPr algn="ctr">
-              <a:defRPr sz="1200" b="1">
+              <a:defRPr b="1" sz="1200">
                 <a:solidFill>
                   <a:srgbClr val="0B1A3A"/>
                 </a:solidFill>
@@ -6992,21 +6803,8 @@
               </a:defRPr>
             </a:pPr>
             <a:r>
-              <a:rPr sz="1400" dirty="0"/>
               <a:t>Technical Preparation</a:t>
             </a:r>
-            <a:endParaRPr lang="en-US" sz="1400" dirty="0"/>
-          </a:p>
-          <a:p>
-            <a:pPr algn="ctr">
-              <a:defRPr sz="1200" b="1">
-                <a:solidFill>
-                  <a:srgbClr val="0B1A3A"/>
-                </a:solidFill>
-                <a:latin typeface="Calibri"/>
-              </a:defRPr>
-            </a:pPr>
-            <a:endParaRPr sz="1400" dirty="0"/>
           </a:p>
           <a:p>
             <a:pPr>
@@ -7021,8 +6819,7 @@
               </a:defRPr>
             </a:pPr>
             <a:r>
-              <a:rPr sz="1400" dirty="0"/>
-              <a:t>• Coding practice &amp; output prediction</a:t>
+              <a:t>• Aptitude training</a:t>
             </a:r>
           </a:p>
           <a:p>
@@ -7038,8 +6835,7 @@
               </a:defRPr>
             </a:pPr>
             <a:r>
-              <a:rPr sz="1400" dirty="0"/>
-              <a:t>• Problem solving drills</a:t>
+              <a:t>• Coding practice &amp; output prediction</a:t>
             </a:r>
           </a:p>
           <a:p>
@@ -7055,7 +6851,22 @@
               </a:defRPr>
             </a:pPr>
             <a:r>
-              <a:rPr sz="1400" dirty="0"/>
+              <a:t>• Problem solving drills</a:t>
+            </a:r>
+          </a:p>
+          <a:p>
+            <a:pPr>
+              <a:spcBef>
+                <a:spcPts val="400"/>
+              </a:spcBef>
+              <a:defRPr sz="1000">
+                <a:solidFill>
+                  <a:srgbClr val="334155"/>
+                </a:solidFill>
+                <a:latin typeface="Calibri"/>
+              </a:defRPr>
+            </a:pPr>
+            <a:r>
               <a:t>• Mock technical interviews</a:t>
             </a:r>
           </a:p>
@@ -7099,11 +6910,11 @@
           </a:fontRef>
         </p:style>
         <p:txBody>
-          <a:bodyPr wrap="square" lIns="127000" tIns="101600" rIns="127000" rtlCol="0" anchor="ctr"/>
+          <a:bodyPr rtlCol="0" anchor="ctr" wrap="square" lIns="127000" rIns="127000" tIns="101600"/>
           <a:lstStyle/>
           <a:p>
             <a:pPr algn="ctr">
-              <a:defRPr sz="1200" b="1">
+              <a:defRPr b="1" sz="1200">
                 <a:solidFill>
                   <a:srgbClr val="0B1A3A"/>
                 </a:solidFill>
@@ -7111,21 +6922,8 @@
               </a:defRPr>
             </a:pPr>
             <a:r>
-              <a:rPr sz="1400" dirty="0"/>
               <a:t>Professional Skills</a:t>
             </a:r>
-            <a:endParaRPr lang="en-US" sz="1400" dirty="0"/>
-          </a:p>
-          <a:p>
-            <a:pPr algn="ctr">
-              <a:defRPr sz="1200" b="1">
-                <a:solidFill>
-                  <a:srgbClr val="0B1A3A"/>
-                </a:solidFill>
-                <a:latin typeface="Calibri"/>
-              </a:defRPr>
-            </a:pPr>
-            <a:endParaRPr sz="1400" dirty="0"/>
           </a:p>
           <a:p>
             <a:pPr>
@@ -7140,7 +6938,6 @@
               </a:defRPr>
             </a:pPr>
             <a:r>
-              <a:rPr sz="1400" dirty="0"/>
               <a:t>• Communication workshops</a:t>
             </a:r>
           </a:p>
@@ -7157,7 +6954,6 @@
               </a:defRPr>
             </a:pPr>
             <a:r>
-              <a:rPr sz="1400" dirty="0"/>
               <a:t>• Resume building</a:t>
             </a:r>
           </a:p>
@@ -7174,8 +6970,39 @@
               </a:defRPr>
             </a:pPr>
             <a:r>
-              <a:rPr sz="1400" dirty="0"/>
               <a:t>• LinkedIn optimization</a:t>
+            </a:r>
+          </a:p>
+          <a:p>
+            <a:pPr>
+              <a:spcBef>
+                <a:spcPts val="400"/>
+              </a:spcBef>
+              <a:defRPr sz="1000">
+                <a:solidFill>
+                  <a:srgbClr val="334155"/>
+                </a:solidFill>
+                <a:latin typeface="Calibri"/>
+              </a:defRPr>
+            </a:pPr>
+            <a:r>
+              <a:t>• Group discussions</a:t>
+            </a:r>
+          </a:p>
+          <a:p>
+            <a:pPr>
+              <a:spcBef>
+                <a:spcPts val="400"/>
+              </a:spcBef>
+              <a:defRPr sz="1000">
+                <a:solidFill>
+                  <a:srgbClr val="334155"/>
+                </a:solidFill>
+                <a:latin typeface="Calibri"/>
+              </a:defRPr>
+            </a:pPr>
+            <a:r>
+              <a:t>• HR interview preparation</a:t>
             </a:r>
           </a:p>
         </p:txBody>
@@ -7218,11 +7045,11 @@
           </a:fontRef>
         </p:style>
         <p:txBody>
-          <a:bodyPr wrap="square" lIns="127000" tIns="101600" rIns="127000" rtlCol="0" anchor="ctr"/>
+          <a:bodyPr rtlCol="0" anchor="ctr" wrap="square" lIns="127000" rIns="127000" tIns="101600"/>
           <a:lstStyle/>
           <a:p>
             <a:pPr algn="ctr">
-              <a:defRPr sz="1200" b="1">
+              <a:defRPr b="1" sz="1200">
                 <a:solidFill>
                   <a:srgbClr val="0B1A3A"/>
                 </a:solidFill>
@@ -7230,21 +7057,8 @@
               </a:defRPr>
             </a:pPr>
             <a:r>
-              <a:rPr sz="1400" dirty="0"/>
               <a:t>Career Readiness</a:t>
             </a:r>
-            <a:endParaRPr lang="en-US" sz="1400" dirty="0"/>
-          </a:p>
-          <a:p>
-            <a:pPr algn="ctr">
-              <a:defRPr sz="1200" b="1">
-                <a:solidFill>
-                  <a:srgbClr val="0B1A3A"/>
-                </a:solidFill>
-                <a:latin typeface="Calibri"/>
-              </a:defRPr>
-            </a:pPr>
-            <a:endParaRPr sz="1400" dirty="0"/>
           </a:p>
           <a:p>
             <a:pPr>
@@ -7259,8 +7073,7 @@
               </a:defRPr>
             </a:pPr>
             <a:r>
-              <a:rPr sz="1400" dirty="0"/>
-              <a:t>• Workplace etiquette</a:t>
+              <a:t>• Personal branding</a:t>
             </a:r>
           </a:p>
           <a:p>
@@ -7276,8 +7089,7 @@
               </a:defRPr>
             </a:pPr>
             <a:r>
-              <a:rPr sz="1400" dirty="0"/>
-              <a:t>• Corporate communication</a:t>
+              <a:t>• Workplace etiquette</a:t>
             </a:r>
           </a:p>
           <a:p>
@@ -7293,7 +7105,22 @@
               </a:defRPr>
             </a:pPr>
             <a:r>
-              <a:rPr sz="1400" dirty="0"/>
+              <a:t>• Corporate communication</a:t>
+            </a:r>
+          </a:p>
+          <a:p>
+            <a:pPr>
+              <a:spcBef>
+                <a:spcPts val="400"/>
+              </a:spcBef>
+              <a:defRPr sz="1000">
+                <a:solidFill>
+                  <a:srgbClr val="334155"/>
+                </a:solidFill>
+                <a:latin typeface="Calibri"/>
+              </a:defRPr>
+            </a:pPr>
+            <a:r>
               <a:t>• Weekly interview prep modules (8 Q&amp;A per week)</a:t>
             </a:r>
           </a:p>
@@ -7360,7 +7187,7 @@
 </file>
 
 <file path=ppt/slides/slide7.xml><?xml version="1.0" encoding="utf-8"?>
-<p:sld xmlns:a="http://schemas.openxmlformats.org/drawingml/2006/main" xmlns:r="http://schemas.openxmlformats.org/officeDocument/2006/relationships" xmlns:p="http://schemas.openxmlformats.org/presentationml/2006/main">
+<p:sld xmlns:a="http://schemas.openxmlformats.org/drawingml/2006/main" xmlns:p="http://schemas.openxmlformats.org/presentationml/2006/main" xmlns:r="http://schemas.openxmlformats.org/officeDocument/2006/relationships">
   <p:cSld>
     <p:bg>
       <p:bgPr>
@@ -7376,14 +7203,7 @@
         <p:cNvGrpSpPr/>
         <p:nvPr/>
       </p:nvGrpSpPr>
-      <p:grpSpPr>
-        <a:xfrm>
-          <a:off x="0" y="0"/>
-          <a:ext cx="0" cy="0"/>
-          <a:chOff x="0" y="0"/>
-          <a:chExt cx="0" cy="0"/>
-        </a:xfrm>
-      </p:grpSpPr>
+      <p:grpSpPr/>
       <p:sp>
         <p:nvSpPr>
           <p:cNvPr id="2" name="Rectangle 1"/>
@@ -7424,7 +7244,6 @@
           <a:lstStyle/>
           <a:p>
             <a:pPr algn="ctr"/>
-            <a:endParaRPr/>
           </a:p>
         </p:txBody>
       </p:sp>
@@ -7502,11 +7321,11 @@
           </a:fontRef>
         </p:style>
         <p:txBody>
-          <a:bodyPr wrap="square" lIns="127000" tIns="101600" rIns="127000" rtlCol="0" anchor="ctr"/>
+          <a:bodyPr rtlCol="0" anchor="ctr" wrap="square" lIns="127000" rIns="127000" tIns="101600"/>
           <a:lstStyle/>
           <a:p>
             <a:pPr algn="ctr">
-              <a:defRPr sz="1200" b="1">
+              <a:defRPr b="1" sz="1200">
                 <a:solidFill>
                   <a:srgbClr val="0B1A3A"/>
                 </a:solidFill>
@@ -7514,17 +7333,14 @@
               </a:defRPr>
             </a:pPr>
             <a:r>
-              <a:rPr sz="1600" dirty="0"/>
               <a:t>Employer Engagement</a:t>
             </a:r>
           </a:p>
           <a:p>
-            <a:pPr marL="171450" indent="-171450">
+            <a:pPr>
               <a:spcBef>
                 <a:spcPts val="400"/>
               </a:spcBef>
-              <a:buFont typeface="Arial" panose="020B0604020202020204" pitchFamily="34" charset="0"/>
-              <a:buChar char="•"/>
               <a:defRPr sz="1000">
                 <a:solidFill>
                   <a:srgbClr val="334155"/>
@@ -7533,17 +7349,14 @@
               </a:defRPr>
             </a:pPr>
             <a:r>
-              <a:rPr sz="1200" dirty="0"/>
               <a:t>Hiring partner network</a:t>
             </a:r>
           </a:p>
           <a:p>
-            <a:pPr marL="171450" indent="-171450">
+            <a:pPr>
               <a:spcBef>
                 <a:spcPts val="400"/>
               </a:spcBef>
-              <a:buFont typeface="Arial" panose="020B0604020202020204" pitchFamily="34" charset="0"/>
-              <a:buChar char="•"/>
               <a:defRPr sz="1000">
                 <a:solidFill>
                   <a:srgbClr val="334155"/>
@@ -7552,17 +7365,14 @@
               </a:defRPr>
             </a:pPr>
             <a:r>
-              <a:rPr sz="1200" dirty="0"/>
               <a:t>Recruitment drives</a:t>
             </a:r>
           </a:p>
           <a:p>
-            <a:pPr marL="171450" indent="-171450">
+            <a:pPr>
               <a:spcBef>
                 <a:spcPts val="400"/>
               </a:spcBef>
-              <a:buFont typeface="Arial" panose="020B0604020202020204" pitchFamily="34" charset="0"/>
-              <a:buChar char="•"/>
               <a:defRPr sz="1000">
                 <a:solidFill>
                   <a:srgbClr val="334155"/>
@@ -7571,17 +7381,14 @@
               </a:defRPr>
             </a:pPr>
             <a:r>
-              <a:rPr sz="1200" dirty="0"/>
               <a:t>Industry referrals</a:t>
             </a:r>
           </a:p>
           <a:p>
-            <a:pPr marL="171450" indent="-171450">
+            <a:pPr>
               <a:spcBef>
                 <a:spcPts val="400"/>
               </a:spcBef>
-              <a:buFont typeface="Arial" panose="020B0604020202020204" pitchFamily="34" charset="0"/>
-              <a:buChar char="•"/>
               <a:defRPr sz="1000">
                 <a:solidFill>
                   <a:srgbClr val="334155"/>
@@ -7590,7 +7397,6 @@
               </a:defRPr>
             </a:pPr>
             <a:r>
-              <a:rPr sz="1200" dirty="0"/>
               <a:t>Talent showcases at hackathon</a:t>
             </a:r>
           </a:p>
@@ -7634,11 +7440,11 @@
           </a:fontRef>
         </p:style>
         <p:txBody>
-          <a:bodyPr wrap="square" lIns="127000" tIns="101600" rIns="127000" rtlCol="0" anchor="ctr"/>
+          <a:bodyPr rtlCol="0" anchor="ctr" wrap="square" lIns="127000" rIns="127000" tIns="101600"/>
           <a:lstStyle/>
           <a:p>
             <a:pPr algn="ctr">
-              <a:defRPr sz="1200" b="1">
+              <a:defRPr b="1" sz="1200">
                 <a:solidFill>
                   <a:srgbClr val="0B1A3A"/>
                 </a:solidFill>
@@ -7646,17 +7452,14 @@
               </a:defRPr>
             </a:pPr>
             <a:r>
-              <a:rPr sz="1600" dirty="0"/>
               <a:t>Student Benefits</a:t>
             </a:r>
           </a:p>
           <a:p>
-            <a:pPr marL="171450" indent="-171450">
+            <a:pPr>
               <a:spcBef>
                 <a:spcPts val="400"/>
               </a:spcBef>
-              <a:buFont typeface="Arial" panose="020B0604020202020204" pitchFamily="34" charset="0"/>
-              <a:buChar char="•"/>
               <a:defRPr sz="1000">
                 <a:solidFill>
                   <a:srgbClr val="334155"/>
@@ -7665,17 +7468,14 @@
               </a:defRPr>
             </a:pPr>
             <a:r>
-              <a:rPr sz="1200" dirty="0"/>
               <a:t>Increased placement opportunities</a:t>
             </a:r>
           </a:p>
           <a:p>
-            <a:pPr marL="171450" indent="-171450">
+            <a:pPr>
               <a:spcBef>
                 <a:spcPts val="400"/>
               </a:spcBef>
-              <a:buFont typeface="Arial" panose="020B0604020202020204" pitchFamily="34" charset="0"/>
-              <a:buChar char="•"/>
               <a:defRPr sz="1000">
                 <a:solidFill>
                   <a:srgbClr val="334155"/>
@@ -7684,17 +7484,14 @@
               </a:defRPr>
             </a:pPr>
             <a:r>
-              <a:rPr sz="1200" dirty="0"/>
               <a:t>Industry visibility</a:t>
             </a:r>
           </a:p>
           <a:p>
-            <a:pPr marL="171450" indent="-171450">
+            <a:pPr>
               <a:spcBef>
                 <a:spcPts val="400"/>
               </a:spcBef>
-              <a:buFont typeface="Arial" panose="020B0604020202020204" pitchFamily="34" charset="0"/>
-              <a:buChar char="•"/>
               <a:defRPr sz="1000">
                 <a:solidFill>
                   <a:srgbClr val="334155"/>
@@ -7703,17 +7500,14 @@
               </a:defRPr>
             </a:pPr>
             <a:r>
-              <a:rPr sz="1200" dirty="0"/>
               <a:t>Strong professional profile</a:t>
             </a:r>
           </a:p>
           <a:p>
-            <a:pPr marL="171450" indent="-171450">
+            <a:pPr>
               <a:spcBef>
                 <a:spcPts val="400"/>
               </a:spcBef>
-              <a:buFont typeface="Arial" panose="020B0604020202020204" pitchFamily="34" charset="0"/>
-              <a:buChar char="•"/>
               <a:defRPr sz="1000">
                 <a:solidFill>
                   <a:srgbClr val="334155"/>
@@ -7722,7 +7516,6 @@
               </a:defRPr>
             </a:pPr>
             <a:r>
-              <a:rPr sz="1200" dirty="0"/>
               <a:t>Job readiness confidence</a:t>
             </a:r>
           </a:p>
@@ -7766,11 +7559,11 @@
           </a:fontRef>
         </p:style>
         <p:txBody>
-          <a:bodyPr wrap="square" lIns="127000" tIns="101600" rIns="127000" rtlCol="0" anchor="ctr"/>
+          <a:bodyPr rtlCol="0" anchor="ctr" wrap="square" lIns="127000" rIns="127000" tIns="101600"/>
           <a:lstStyle/>
           <a:p>
             <a:pPr algn="ctr">
-              <a:defRPr sz="1200" b="1">
+              <a:defRPr b="1" sz="1200">
                 <a:solidFill>
                   <a:srgbClr val="0B1A3A"/>
                 </a:solidFill>
@@ -7778,17 +7571,14 @@
               </a:defRPr>
             </a:pPr>
             <a:r>
-              <a:rPr sz="1600" dirty="0"/>
               <a:t>Top Performers</a:t>
             </a:r>
           </a:p>
           <a:p>
-            <a:pPr marL="171450" indent="-171450">
+            <a:pPr>
               <a:spcBef>
                 <a:spcPts val="400"/>
               </a:spcBef>
-              <a:buFont typeface="Arial" panose="020B0604020202020204" pitchFamily="34" charset="0"/>
-              <a:buChar char="•"/>
               <a:defRPr sz="1000">
                 <a:solidFill>
                   <a:srgbClr val="334155"/>
@@ -7797,17 +7587,14 @@
               </a:defRPr>
             </a:pPr>
             <a:r>
-              <a:rPr sz="1200" dirty="0"/>
               <a:t>Top 5% → Paid internship (performance-based stipend)</a:t>
             </a:r>
           </a:p>
           <a:p>
-            <a:pPr marL="171450" indent="-171450">
+            <a:pPr>
               <a:spcBef>
                 <a:spcPts val="400"/>
               </a:spcBef>
-              <a:buFont typeface="Arial" panose="020B0604020202020204" pitchFamily="34" charset="0"/>
-              <a:buChar char="•"/>
               <a:defRPr sz="1000">
                 <a:solidFill>
                   <a:srgbClr val="334155"/>
@@ -7816,29 +7603,253 @@
               </a:defRPr>
             </a:pPr>
             <a:r>
-              <a:rPr sz="1200" dirty="0"/>
+              <a:t>Top 5% → Placement assurity pathway</a:t>
+            </a:r>
+          </a:p>
+          <a:p>
+            <a:pPr>
+              <a:spcBef>
+                <a:spcPts val="400"/>
+              </a:spcBef>
+              <a:defRPr sz="1000">
+                <a:solidFill>
+                  <a:srgbClr val="334155"/>
+                </a:solidFill>
+                <a:latin typeface="Calibri"/>
+              </a:defRPr>
+            </a:pPr>
+            <a:r>
               <a:t>Hackathon winners prioritized</a:t>
             </a:r>
-            <a:endParaRPr sz="1100" dirty="0"/>
-          </a:p>
-        </p:txBody>
-      </p:sp>
+          </a:p>
+        </p:txBody>
+      </p:sp>
+      <p:graphicFrame>
+        <p:nvGraphicFramePr>
+          <p:cNvPr id="7" name="Table 6"/>
+          <p:cNvGraphicFramePr>
+            <a:graphicFrameLocks noGrp="1"/>
+          </p:cNvGraphicFramePr>
+          <p:nvPr/>
+        </p:nvGraphicFramePr>
+        <p:xfrm>
+          <a:off x="502920" y="3429000"/>
+          <a:ext cx="8138160" cy="1005840"/>
+        </p:xfrm>
+        <a:graphic>
+          <a:graphicData uri="http://schemas.openxmlformats.org/drawingml/2006/table">
+            <a:tbl>
+              <a:tblPr firstRow="1" bandRow="1">
+                <a:tableStyleId>{5C22544A-7EE6-4342-B048-85BDC9FD1C3A}</a:tableStyleId>
+              </a:tblPr>
+              <a:tblGrid>
+                <a:gridCol w="2034540"/>
+                <a:gridCol w="2034540"/>
+                <a:gridCol w="2034540"/>
+                <a:gridCol w="2034540"/>
+              </a:tblGrid>
+              <a:tr h="502920">
+                <a:tc>
+                  <a:txBody>
+                    <a:bodyPr/>
+                    <a:lstStyle/>
+                    <a:p>
+                      <a:pPr algn="ctr">
+                        <a:defRPr sz="1100" b="0">
+                          <a:solidFill>
+                            <a:srgbClr val="FFFFFF"/>
+                          </a:solidFill>
+                        </a:defRPr>
+                      </a:pPr>
+                      <a:r>
+                        <a:t>Students Trained</a:t>
+                      </a:r>
+                    </a:p>
+                  </a:txBody>
+                  <a:tcPr anchor="ctr">
+                    <a:solidFill>
+                      <a:srgbClr val="0B1A3A"/>
+                    </a:solidFill>
+                  </a:tcPr>
+                </a:tc>
+                <a:tc>
+                  <a:txBody>
+                    <a:bodyPr/>
+                    <a:lstStyle/>
+                    <a:p>
+                      <a:pPr algn="ctr">
+                        <a:defRPr sz="1100" b="0">
+                          <a:solidFill>
+                            <a:srgbClr val="FFFFFF"/>
+                          </a:solidFill>
+                        </a:defRPr>
+                      </a:pPr>
+                      <a:r>
+                        <a:t>Projects Completed</a:t>
+                      </a:r>
+                    </a:p>
+                  </a:txBody>
+                  <a:tcPr anchor="ctr">
+                    <a:solidFill>
+                      <a:srgbClr val="0B1A3A"/>
+                    </a:solidFill>
+                  </a:tcPr>
+                </a:tc>
+                <a:tc>
+                  <a:txBody>
+                    <a:bodyPr/>
+                    <a:lstStyle/>
+                    <a:p>
+                      <a:pPr algn="ctr">
+                        <a:defRPr sz="1100" b="0">
+                          <a:solidFill>
+                            <a:srgbClr val="FFFFFF"/>
+                          </a:solidFill>
+                        </a:defRPr>
+                      </a:pPr>
+                      <a:r>
+                        <a:t>Hiring Partners</a:t>
+                      </a:r>
+                    </a:p>
+                  </a:txBody>
+                  <a:tcPr anchor="ctr">
+                    <a:solidFill>
+                      <a:srgbClr val="0B1A3A"/>
+                    </a:solidFill>
+                  </a:tcPr>
+                </a:tc>
+                <a:tc>
+                  <a:txBody>
+                    <a:bodyPr/>
+                    <a:lstStyle/>
+                    <a:p>
+                      <a:pPr algn="ctr">
+                        <a:defRPr sz="1100" b="0">
+                          <a:solidFill>
+                            <a:srgbClr val="FFFFFF"/>
+                          </a:solidFill>
+                        </a:defRPr>
+                      </a:pPr>
+                      <a:r>
+                        <a:t>Placement Success Rate</a:t>
+                      </a:r>
+                    </a:p>
+                  </a:txBody>
+                  <a:tcPr anchor="ctr">
+                    <a:solidFill>
+                      <a:srgbClr val="0B1A3A"/>
+                    </a:solidFill>
+                  </a:tcPr>
+                </a:tc>
+              </a:tr>
+              <a:tr h="502920">
+                <a:tc>
+                  <a:txBody>
+                    <a:bodyPr/>
+                    <a:lstStyle/>
+                    <a:p>
+                      <a:pPr algn="ctr">
+                        <a:defRPr sz="1600" b="1">
+                          <a:solidFill>
+                            <a:srgbClr val="0B1A3A"/>
+                          </a:solidFill>
+                        </a:defRPr>
+                      </a:pPr>
+                      <a:r>
+                        <a:t>[___]+</a:t>
+                      </a:r>
+                    </a:p>
+                  </a:txBody>
+                  <a:tcPr anchor="ctr">
+                    <a:solidFill>
+                      <a:srgbClr val="F1F5F9"/>
+                    </a:solidFill>
+                  </a:tcPr>
+                </a:tc>
+                <a:tc>
+                  <a:txBody>
+                    <a:bodyPr/>
+                    <a:lstStyle/>
+                    <a:p>
+                      <a:pPr algn="ctr">
+                        <a:defRPr sz="1600" b="1">
+                          <a:solidFill>
+                            <a:srgbClr val="0B1A3A"/>
+                          </a:solidFill>
+                        </a:defRPr>
+                      </a:pPr>
+                      <a:r>
+                        <a:t>[___]+</a:t>
+                      </a:r>
+                    </a:p>
+                  </a:txBody>
+                  <a:tcPr anchor="ctr">
+                    <a:solidFill>
+                      <a:srgbClr val="F1F5F9"/>
+                    </a:solidFill>
+                  </a:tcPr>
+                </a:tc>
+                <a:tc>
+                  <a:txBody>
+                    <a:bodyPr/>
+                    <a:lstStyle/>
+                    <a:p>
+                      <a:pPr algn="ctr">
+                        <a:defRPr sz="1600" b="1">
+                          <a:solidFill>
+                            <a:srgbClr val="0B1A3A"/>
+                          </a:solidFill>
+                        </a:defRPr>
+                      </a:pPr>
+                      <a:r>
+                        <a:t>[___]+</a:t>
+                      </a:r>
+                    </a:p>
+                  </a:txBody>
+                  <a:tcPr anchor="ctr">
+                    <a:solidFill>
+                      <a:srgbClr val="F1F5F9"/>
+                    </a:solidFill>
+                  </a:tcPr>
+                </a:tc>
+                <a:tc>
+                  <a:txBody>
+                    <a:bodyPr/>
+                    <a:lstStyle/>
+                    <a:p>
+                      <a:pPr algn="ctr">
+                        <a:defRPr sz="1600" b="1">
+                          <a:solidFill>
+                            <a:srgbClr val="0B1A3A"/>
+                          </a:solidFill>
+                        </a:defRPr>
+                      </a:pPr>
+                      <a:r>
+                        <a:t>[___]%</a:t>
+                      </a:r>
+                    </a:p>
+                  </a:txBody>
+                  <a:tcPr anchor="ctr">
+                    <a:solidFill>
+                      <a:srgbClr val="F1F5F9"/>
+                    </a:solidFill>
+                  </a:tcPr>
+                </a:tc>
+              </a:tr>
+            </a:tbl>
+          </a:graphicData>
+        </a:graphic>
+      </p:graphicFrame>
       <p:graphicFrame>
         <p:nvGraphicFramePr>
           <p:cNvPr id="8" name="Table 7"/>
           <p:cNvGraphicFramePr>
             <a:graphicFrameLocks noGrp="1"/>
           </p:cNvGraphicFramePr>
-          <p:nvPr>
-            <p:extLst>
-              <p:ext uri="{D42A27DB-BD31-4B8C-83A1-F6EECF244321}">
-                <p14:modId xmlns:p14="http://schemas.microsoft.com/office/powerpoint/2010/main" val="2274412539"/>
-              </p:ext>
-            </p:extLst>
-          </p:nvPr>
+          <p:nvPr/>
         </p:nvGraphicFramePr>
         <p:xfrm>
-          <a:off x="502920" y="4103519"/>
+          <a:off x="502920" y="4709160"/>
           <a:ext cx="3840480" cy="1417320"/>
         </p:xfrm>
         <a:graphic>
@@ -7848,20 +7859,8 @@
                 <a:tableStyleId>{5C22544A-7EE6-4342-B048-85BDC9FD1C3A}</a:tableStyleId>
               </a:tblPr>
               <a:tblGrid>
-                <a:gridCol w="1920240">
-                  <a:extLst>
-                    <a:ext uri="{9D8B030D-6E8A-4147-A177-3AD203B41FA5}">
-                      <a16:colId xmlns:a16="http://schemas.microsoft.com/office/drawing/2014/main" val="20000"/>
-                    </a:ext>
-                  </a:extLst>
-                </a:gridCol>
-                <a:gridCol w="1920240">
-                  <a:extLst>
-                    <a:ext uri="{9D8B030D-6E8A-4147-A177-3AD203B41FA5}">
-                      <a16:colId xmlns:a16="http://schemas.microsoft.com/office/drawing/2014/main" val="20001"/>
-                    </a:ext>
-                  </a:extLst>
-                </a:gridCol>
+                <a:gridCol w="1920240"/>
+                <a:gridCol w="1920240"/>
               </a:tblGrid>
               <a:tr h="354330">
                 <a:tc>
@@ -7910,11 +7909,6 @@
                     </a:solidFill>
                   </a:tcPr>
                 </a:tc>
-                <a:extLst>
-                  <a:ext uri="{0D108BD9-81ED-4DB2-BD59-A6C34878D82A}">
-                    <a16:rowId xmlns:a16="http://schemas.microsoft.com/office/drawing/2014/main" val="10000"/>
-                  </a:ext>
-                </a:extLst>
               </a:tr>
               <a:tr h="354330">
                 <a:tc>
@@ -7955,11 +7949,6 @@
                   </a:txBody>
                   <a:tcPr/>
                 </a:tc>
-                <a:extLst>
-                  <a:ext uri="{0D108BD9-81ED-4DB2-BD59-A6C34878D82A}">
-                    <a16:rowId xmlns:a16="http://schemas.microsoft.com/office/drawing/2014/main" val="10001"/>
-                  </a:ext>
-                </a:extLst>
               </a:tr>
               <a:tr h="354330">
                 <a:tc>
@@ -8000,11 +7989,6 @@
                   </a:txBody>
                   <a:tcPr/>
                 </a:tc>
-                <a:extLst>
-                  <a:ext uri="{0D108BD9-81ED-4DB2-BD59-A6C34878D82A}">
-                    <a16:rowId xmlns:a16="http://schemas.microsoft.com/office/drawing/2014/main" val="10002"/>
-                  </a:ext>
-                </a:extLst>
               </a:tr>
               <a:tr h="354330">
                 <a:tc>
@@ -8039,18 +8023,12 @@
                         </a:defRPr>
                       </a:pPr>
                       <a:r>
-                        <a:rPr dirty="0"/>
                         <a:t>₹11,999</a:t>
                       </a:r>
                     </a:p>
                   </a:txBody>
                   <a:tcPr/>
                 </a:tc>
-                <a:extLst>
-                  <a:ext uri="{0D108BD9-81ED-4DB2-BD59-A6C34878D82A}">
-                    <a16:rowId xmlns:a16="http://schemas.microsoft.com/office/drawing/2014/main" val="10003"/>
-                  </a:ext>
-                </a:extLst>
               </a:tr>
             </a:tbl>
           </a:graphicData>
@@ -8064,7 +8042,7 @@
         </p:nvSpPr>
         <p:spPr>
           <a:xfrm>
-            <a:off x="4549140" y="4103519"/>
+            <a:off x="4572000" y="4709160"/>
             <a:ext cx="4069080" cy="1417320"/>
           </a:xfrm>
           <a:prstGeom prst="roundRect">
@@ -8096,7 +8074,7 @@
           <a:lstStyle/>
           <a:p>
             <a:pPr>
-              <a:defRPr sz="1200" b="1">
+              <a:defRPr b="1" sz="1200">
                 <a:solidFill>
                   <a:srgbClr val="22D3EE"/>
                 </a:solidFill>
@@ -8129,7 +8107,7 @@
 </file>
 
 <file path=ppt/slides/slide8.xml><?xml version="1.0" encoding="utf-8"?>
-<p:sld xmlns:a="http://schemas.openxmlformats.org/drawingml/2006/main" xmlns:r="http://schemas.openxmlformats.org/officeDocument/2006/relationships" xmlns:p="http://schemas.openxmlformats.org/presentationml/2006/main">
+<p:sld xmlns:a="http://schemas.openxmlformats.org/drawingml/2006/main" xmlns:p="http://schemas.openxmlformats.org/presentationml/2006/main" xmlns:r="http://schemas.openxmlformats.org/officeDocument/2006/relationships">
   <p:cSld>
     <p:bg>
       <p:bgPr>
@@ -8145,14 +8123,7 @@
         <p:cNvGrpSpPr/>
         <p:nvPr/>
       </p:nvGrpSpPr>
-      <p:grpSpPr>
-        <a:xfrm>
-          <a:off x="0" y="0"/>
-          <a:ext cx="0" cy="0"/>
-          <a:chOff x="0" y="0"/>
-          <a:chExt cx="0" cy="0"/>
-        </a:xfrm>
-      </p:grpSpPr>
+      <p:grpSpPr/>
       <p:sp>
         <p:nvSpPr>
           <p:cNvPr id="2" name="Rectangle 1"/>
@@ -8193,10 +8164,33 @@
           <a:lstStyle/>
           <a:p>
             <a:pPr algn="ctr"/>
-            <a:endParaRPr/>
-          </a:p>
-        </p:txBody>
-      </p:sp>
+          </a:p>
+        </p:txBody>
+      </p:sp>
+      <p:pic>
+        <p:nvPicPr>
+          <p:cNvPr id="3" name="Picture 2" descr="mantra-ai-favicon.png"/>
+          <p:cNvPicPr>
+            <a:picLocks noChangeAspect="1"/>
+          </p:cNvPicPr>
+          <p:nvPr/>
+        </p:nvPicPr>
+        <p:blipFill>
+          <a:blip r:embed="rId2"/>
+          <a:stretch>
+            <a:fillRect/>
+          </a:stretch>
+        </p:blipFill>
+        <p:spPr>
+          <a:xfrm>
+            <a:off x="4069080" y="594360"/>
+            <a:ext cx="1005840" cy="1005840"/>
+          </a:xfrm>
+          <a:prstGeom prst="rect">
+            <a:avLst/>
+          </a:prstGeom>
+        </p:spPr>
+      </p:pic>
       <p:sp>
         <p:nvSpPr>
           <p:cNvPr id="4" name="TextBox 3"/>
@@ -8206,7 +8200,7 @@
         <p:spPr>
           <a:xfrm>
             <a:off x="502920" y="1691640"/>
-            <a:ext cx="7803290" cy="553998"/>
+            <a:ext cx="8229600" cy="685800"/>
           </a:xfrm>
           <a:prstGeom prst="rect">
             <a:avLst/>
@@ -8214,7 +8208,7 @@
           <a:noFill/>
         </p:spPr>
         <p:txBody>
-          <a:bodyPr wrap="square">
+          <a:bodyPr wrap="none">
             <a:spAutoFit/>
           </a:bodyPr>
           <a:lstStyle/>
@@ -8228,11 +8222,6 @@
               </a:defRPr>
             </a:pPr>
             <a:r>
-              <a:rPr lang="en-US" dirty="0"/>
-              <a:t>		</a:t>
-            </a:r>
-            <a:r>
-              <a:rPr dirty="0"/>
               <a:t>Let's Build Industry-Ready Talent Together</a:t>
             </a:r>
           </a:p>
@@ -8335,8 +8324,8 @@
         </p:nvSpPr>
         <p:spPr>
           <a:xfrm>
-            <a:off x="2501722" y="4572000"/>
-            <a:ext cx="4140557" cy="707886"/>
+            <a:off x="822960" y="4572000"/>
+            <a:ext cx="7498079" cy="1371600"/>
           </a:xfrm>
           <a:prstGeom prst="rect">
             <a:avLst/>
@@ -8350,14 +8339,13 @@
           <a:lstStyle/>
           <a:p>
             <a:pPr algn="ctr">
-              <a:defRPr sz="1400" b="1">
+              <a:defRPr b="1" sz="1400">
                 <a:solidFill>
                   <a:srgbClr val="22D3EE"/>
                 </a:solidFill>
               </a:defRPr>
             </a:pPr>
             <a:r>
-              <a:rPr dirty="0"/>
               <a:t>Contact</a:t>
             </a:r>
           </a:p>
@@ -8370,14 +8358,8 @@
               </a:defRPr>
             </a:pPr>
             <a:r>
-              <a:rPr dirty="0"/>
-              <a:t>Praveen Manoharan — </a:t>
-            </a:r>
-            <a:r>
-              <a:rPr lang="en-US" dirty="0"/>
-              <a:t>CTO &amp; Technical Program Manager</a:t>
-            </a:r>
-            <a:endParaRPr dirty="0"/>
+              <a:t>Praveen Manoharan — Program Lead</a:t>
+            </a:r>
           </a:p>
           <a:p>
             <a:pPr algn="ctr">
@@ -8388,8 +8370,19 @@
               </a:defRPr>
             </a:pPr>
             <a:r>
-              <a:rPr dirty="0"/>
               <a:t>+91 8760 8760 62</a:t>
+            </a:r>
+          </a:p>
+          <a:p>
+            <a:pPr algn="ctr">
+              <a:defRPr sz="1300">
+                <a:solidFill>
+                  <a:srgbClr val="FFFFFF"/>
+                </a:solidFill>
+              </a:defRPr>
+            </a:pPr>
+            <a:r>
+              <a:t>AI NextGen Industry Readiness Internship Program</a:t>
             </a:r>
           </a:p>
         </p:txBody>

</xml_diff>